<commit_message>
feat(my-design-style): AssetUseCheck delivery, series variation, and SVG rasterization
Require AssetUseCheck for non-wireframe artifacts, add Default Series Selection and richness/restreaint balance in shared mechanics, and document RGBA vector conversion for embed-limited media. Refresh the chinese_traditional guide deck example with rasterized motifs, new assets, and asset_use_check.json output.

Co-authored-by: Cursor <cursoragent@cursor.com>
</commit_message>
<xml_diff>
--- a/skills/my-design-style/examples/chinese_traditional_guide_deck/chinese_traditional_guide_deck.pptx
+++ b/skills/my-design-style/examples/chinese_traditional_guide_deck/chinese_traditional_guide_deck.pptx
@@ -1,21 +1,21 @@
 
 <file path=ppt/presentation.xml><?xml version="1.0" encoding="utf-8"?>
-<p:presentation xmlns:a="http://schemas.openxmlformats.org/drawingml/2006/main" xmlns:r="http://schemas.openxmlformats.org/officeDocument/2006/relationships" xmlns:p="http://schemas.openxmlformats.org/presentationml/2006/main" autoCompressPictures="0">
+<p:presentation xmlns:a="http://schemas.openxmlformats.org/drawingml/2006/main" xmlns:r="http://schemas.openxmlformats.org/officeDocument/2006/relationships" xmlns:p="http://schemas.openxmlformats.org/presentationml/2006/main" saveSubsetFonts="1" autoCompressPictures="0">
   <p:sldMasterIdLst>
     <p:sldMasterId id="2147483648" r:id="rId1"/>
   </p:sldMasterIdLst>
   <p:sldIdLst>
-    <p:sldId id="256" r:id="rId3"/>
-    <p:sldId id="257" r:id="rId4"/>
-    <p:sldId id="258" r:id="rId5"/>
-    <p:sldId id="259" r:id="rId6"/>
-    <p:sldId id="260" r:id="rId7"/>
-    <p:sldId id="261" r:id="rId8"/>
-    <p:sldId id="262" r:id="rId9"/>
-    <p:sldId id="263" r:id="rId10"/>
-    <p:sldId id="264" r:id="rId11"/>
+    <p:sldId id="256" r:id="rId7"/>
+    <p:sldId id="257" r:id="rId8"/>
+    <p:sldId id="258" r:id="rId9"/>
+    <p:sldId id="259" r:id="rId10"/>
+    <p:sldId id="260" r:id="rId11"/>
+    <p:sldId id="261" r:id="rId12"/>
+    <p:sldId id="262" r:id="rId13"/>
+    <p:sldId id="263" r:id="rId14"/>
+    <p:sldId id="264" r:id="rId15"/>
   </p:sldIdLst>
-  <p:sldSz cx="12191365" cy="6858000" type="screen4x3"/>
+  <p:sldSz cx="12191695" cy="6858000" type="screen4x3"/>
   <p:notesSz cx="6858000" cy="9144000"/>
   <p:defaultTextStyle>
     <a:defPPr>
@@ -112,22 +112,6 @@
       </a:defRPr>
     </a:lvl9pPr>
   </p:defaultTextStyle>
-  <p:extLst>
-    <p:ext uri="{EFAFB233-063F-42B5-8137-9DF3F51BA10A}">
-      <p15:sldGuideLst xmlns:p15="http://schemas.microsoft.com/office/powerpoint/2012/main">
-        <p15:guide id="1" orient="horz" pos="2155" userDrawn="1">
-          <p15:clr>
-            <a:srgbClr val="A4A3A4"/>
-          </p15:clr>
-        </p15:guide>
-        <p15:guide id="2" pos="2880" userDrawn="1">
-          <p15:clr>
-            <a:srgbClr val="A4A3A4"/>
-          </p15:clr>
-        </p15:guide>
-      </p15:sldGuideLst>
-    </p:ext>
-  </p:extLst>
 </p:presentation>
 </file>
 
@@ -312,6 +296,7 @@
           <a:p>
             <a:fld id="{5BCAD085-E8A6-8845-BD4E-CB4CCA059FC4}" type="datetimeFigureOut">
               <a:rPr lang="en-US" smtClean="0"/>
+              <a:t>1/27/13</a:t>
             </a:fld>
             <a:endParaRPr lang="en-US"/>
           </a:p>
@@ -353,12 +338,18 @@
           <a:p>
             <a:fld id="{C1FF6DA9-008F-8B48-92A6-B652298478BF}" type="slidenum">
               <a:rPr lang="en-US" smtClean="0"/>
+              <a:t>‹#›</a:t>
             </a:fld>
             <a:endParaRPr lang="en-US"/>
           </a:p>
         </p:txBody>
       </p:sp>
     </p:spTree>
+    <p:extLst>
+      <p:ext uri="{BB962C8B-B14F-4D97-AF65-F5344CB8AC3E}">
+        <p14:creationId xmlns:p14="http://schemas.microsoft.com/office/powerpoint/2010/main" val="3168075583"/>
+      </p:ext>
+    </p:extLst>
   </p:cSld>
   <p:clrMapOvr>
     <a:masterClrMapping/>
@@ -426,7 +417,6 @@
               <a:rPr lang="en-US" smtClean="0"/>
               <a:t>Click to edit Master text styles</a:t>
             </a:r>
-            <a:endParaRPr lang="en-US" smtClean="0"/>
           </a:p>
           <a:p>
             <a:pPr lvl="1"/>
@@ -434,7 +424,6 @@
               <a:rPr lang="en-US" smtClean="0"/>
               <a:t>Second level</a:t>
             </a:r>
-            <a:endParaRPr lang="en-US" smtClean="0"/>
           </a:p>
           <a:p>
             <a:pPr lvl="2"/>
@@ -442,7 +431,6 @@
               <a:rPr lang="en-US" smtClean="0"/>
               <a:t>Third level</a:t>
             </a:r>
-            <a:endParaRPr lang="en-US" smtClean="0"/>
           </a:p>
           <a:p>
             <a:pPr lvl="3"/>
@@ -450,7 +438,6 @@
               <a:rPr lang="en-US" smtClean="0"/>
               <a:t>Fourth level</a:t>
             </a:r>
-            <a:endParaRPr lang="en-US" smtClean="0"/>
           </a:p>
           <a:p>
             <a:pPr lvl="4"/>
@@ -479,6 +466,7 @@
           <a:p>
             <a:fld id="{5BCAD085-E8A6-8845-BD4E-CB4CCA059FC4}" type="datetimeFigureOut">
               <a:rPr lang="en-US" smtClean="0"/>
+              <a:t>1/27/13</a:t>
             </a:fld>
             <a:endParaRPr lang="en-US"/>
           </a:p>
@@ -520,12 +508,18 @@
           <a:p>
             <a:fld id="{C1FF6DA9-008F-8B48-92A6-B652298478BF}" type="slidenum">
               <a:rPr lang="en-US" smtClean="0"/>
+              <a:t>‹#›</a:t>
             </a:fld>
             <a:endParaRPr lang="en-US"/>
           </a:p>
         </p:txBody>
       </p:sp>
     </p:spTree>
+    <p:extLst>
+      <p:ext uri="{BB962C8B-B14F-4D97-AF65-F5344CB8AC3E}">
+        <p14:creationId xmlns:p14="http://schemas.microsoft.com/office/powerpoint/2010/main" val="2910927964"/>
+      </p:ext>
+    </p:extLst>
   </p:cSld>
   <p:clrMapOvr>
     <a:masterClrMapping/>
@@ -603,7 +597,6 @@
               <a:rPr lang="en-US" smtClean="0"/>
               <a:t>Click to edit Master text styles</a:t>
             </a:r>
-            <a:endParaRPr lang="en-US" smtClean="0"/>
           </a:p>
           <a:p>
             <a:pPr lvl="1"/>
@@ -611,7 +604,6 @@
               <a:rPr lang="en-US" smtClean="0"/>
               <a:t>Second level</a:t>
             </a:r>
-            <a:endParaRPr lang="en-US" smtClean="0"/>
           </a:p>
           <a:p>
             <a:pPr lvl="2"/>
@@ -619,7 +611,6 @@
               <a:rPr lang="en-US" smtClean="0"/>
               <a:t>Third level</a:t>
             </a:r>
-            <a:endParaRPr lang="en-US" smtClean="0"/>
           </a:p>
           <a:p>
             <a:pPr lvl="3"/>
@@ -627,7 +618,6 @@
               <a:rPr lang="en-US" smtClean="0"/>
               <a:t>Fourth level</a:t>
             </a:r>
-            <a:endParaRPr lang="en-US" smtClean="0"/>
           </a:p>
           <a:p>
             <a:pPr lvl="4"/>
@@ -656,6 +646,7 @@
           <a:p>
             <a:fld id="{5BCAD085-E8A6-8845-BD4E-CB4CCA059FC4}" type="datetimeFigureOut">
               <a:rPr lang="en-US" smtClean="0"/>
+              <a:t>1/27/13</a:t>
             </a:fld>
             <a:endParaRPr lang="en-US"/>
           </a:p>
@@ -697,12 +688,18 @@
           <a:p>
             <a:fld id="{C1FF6DA9-008F-8B48-92A6-B652298478BF}" type="slidenum">
               <a:rPr lang="en-US" smtClean="0"/>
+              <a:t>‹#›</a:t>
             </a:fld>
             <a:endParaRPr lang="en-US"/>
           </a:p>
         </p:txBody>
       </p:sp>
     </p:spTree>
+    <p:extLst>
+      <p:ext uri="{BB962C8B-B14F-4D97-AF65-F5344CB8AC3E}">
+        <p14:creationId xmlns:p14="http://schemas.microsoft.com/office/powerpoint/2010/main" val="3612223792"/>
+      </p:ext>
+    </p:extLst>
   </p:cSld>
   <p:clrMapOvr>
     <a:masterClrMapping/>
@@ -770,7 +767,6 @@
               <a:rPr lang="en-US" smtClean="0"/>
               <a:t>Click to edit Master text styles</a:t>
             </a:r>
-            <a:endParaRPr lang="en-US" smtClean="0"/>
           </a:p>
           <a:p>
             <a:pPr lvl="1"/>
@@ -778,7 +774,6 @@
               <a:rPr lang="en-US" smtClean="0"/>
               <a:t>Second level</a:t>
             </a:r>
-            <a:endParaRPr lang="en-US" smtClean="0"/>
           </a:p>
           <a:p>
             <a:pPr lvl="2"/>
@@ -786,7 +781,6 @@
               <a:rPr lang="en-US" smtClean="0"/>
               <a:t>Third level</a:t>
             </a:r>
-            <a:endParaRPr lang="en-US" smtClean="0"/>
           </a:p>
           <a:p>
             <a:pPr lvl="3"/>
@@ -794,7 +788,6 @@
               <a:rPr lang="en-US" smtClean="0"/>
               <a:t>Fourth level</a:t>
             </a:r>
-            <a:endParaRPr lang="en-US" smtClean="0"/>
           </a:p>
           <a:p>
             <a:pPr lvl="4"/>
@@ -823,6 +816,7 @@
           <a:p>
             <a:fld id="{5BCAD085-E8A6-8845-BD4E-CB4CCA059FC4}" type="datetimeFigureOut">
               <a:rPr lang="en-US" smtClean="0"/>
+              <a:t>1/27/13</a:t>
             </a:fld>
             <a:endParaRPr lang="en-US"/>
           </a:p>
@@ -864,12 +858,18 @@
           <a:p>
             <a:fld id="{C1FF6DA9-008F-8B48-92A6-B652298478BF}" type="slidenum">
               <a:rPr lang="en-US" smtClean="0"/>
+              <a:t>‹#›</a:t>
             </a:fld>
             <a:endParaRPr lang="en-US"/>
           </a:p>
         </p:txBody>
       </p:sp>
     </p:spTree>
+    <p:extLst>
+      <p:ext uri="{BB962C8B-B14F-4D97-AF65-F5344CB8AC3E}">
+        <p14:creationId xmlns:p14="http://schemas.microsoft.com/office/powerpoint/2010/main" val="2614314258"/>
+      </p:ext>
+    </p:extLst>
   </p:cSld>
   <p:clrMapOvr>
     <a:masterClrMapping/>
@@ -1042,7 +1042,6 @@
               <a:rPr lang="en-US" smtClean="0"/>
               <a:t>Click to edit Master text styles</a:t>
             </a:r>
-            <a:endParaRPr lang="en-US" smtClean="0"/>
           </a:p>
         </p:txBody>
       </p:sp>
@@ -1063,6 +1062,7 @@
           <a:p>
             <a:fld id="{5BCAD085-E8A6-8845-BD4E-CB4CCA059FC4}" type="datetimeFigureOut">
               <a:rPr lang="en-US" smtClean="0"/>
+              <a:t>1/27/13</a:t>
             </a:fld>
             <a:endParaRPr lang="en-US"/>
           </a:p>
@@ -1104,12 +1104,18 @@
           <a:p>
             <a:fld id="{C1FF6DA9-008F-8B48-92A6-B652298478BF}" type="slidenum">
               <a:rPr lang="en-US" smtClean="0"/>
+              <a:t>‹#›</a:t>
             </a:fld>
             <a:endParaRPr lang="en-US"/>
           </a:p>
         </p:txBody>
       </p:sp>
     </p:spTree>
+    <p:extLst>
+      <p:ext uri="{BB962C8B-B14F-4D97-AF65-F5344CB8AC3E}">
+        <p14:creationId xmlns:p14="http://schemas.microsoft.com/office/powerpoint/2010/main" val="960648375"/>
+      </p:ext>
+    </p:extLst>
   </p:cSld>
   <p:clrMapOvr>
     <a:masterClrMapping/>
@@ -1210,7 +1216,6 @@
               <a:rPr lang="en-US" smtClean="0"/>
               <a:t>Click to edit Master text styles</a:t>
             </a:r>
-            <a:endParaRPr lang="en-US" smtClean="0"/>
           </a:p>
           <a:p>
             <a:pPr lvl="1"/>
@@ -1218,7 +1223,6 @@
               <a:rPr lang="en-US" smtClean="0"/>
               <a:t>Second level</a:t>
             </a:r>
-            <a:endParaRPr lang="en-US" smtClean="0"/>
           </a:p>
           <a:p>
             <a:pPr lvl="2"/>
@@ -1226,7 +1230,6 @@
               <a:rPr lang="en-US" smtClean="0"/>
               <a:t>Third level</a:t>
             </a:r>
-            <a:endParaRPr lang="en-US" smtClean="0"/>
           </a:p>
           <a:p>
             <a:pPr lvl="3"/>
@@ -1234,7 +1237,6 @@
               <a:rPr lang="en-US" smtClean="0"/>
               <a:t>Fourth level</a:t>
             </a:r>
-            <a:endParaRPr lang="en-US" smtClean="0"/>
           </a:p>
           <a:p>
             <a:pPr lvl="4"/>
@@ -1299,7 +1301,6 @@
               <a:rPr lang="en-US" smtClean="0"/>
               <a:t>Click to edit Master text styles</a:t>
             </a:r>
-            <a:endParaRPr lang="en-US" smtClean="0"/>
           </a:p>
           <a:p>
             <a:pPr lvl="1"/>
@@ -1307,7 +1308,6 @@
               <a:rPr lang="en-US" smtClean="0"/>
               <a:t>Second level</a:t>
             </a:r>
-            <a:endParaRPr lang="en-US" smtClean="0"/>
           </a:p>
           <a:p>
             <a:pPr lvl="2"/>
@@ -1315,7 +1315,6 @@
               <a:rPr lang="en-US" smtClean="0"/>
               <a:t>Third level</a:t>
             </a:r>
-            <a:endParaRPr lang="en-US" smtClean="0"/>
           </a:p>
           <a:p>
             <a:pPr lvl="3"/>
@@ -1323,7 +1322,6 @@
               <a:rPr lang="en-US" smtClean="0"/>
               <a:t>Fourth level</a:t>
             </a:r>
-            <a:endParaRPr lang="en-US" smtClean="0"/>
           </a:p>
           <a:p>
             <a:pPr lvl="4"/>
@@ -1352,6 +1350,7 @@
           <a:p>
             <a:fld id="{5BCAD085-E8A6-8845-BD4E-CB4CCA059FC4}" type="datetimeFigureOut">
               <a:rPr lang="en-US" smtClean="0"/>
+              <a:t>1/27/13</a:t>
             </a:fld>
             <a:endParaRPr lang="en-US"/>
           </a:p>
@@ -1393,12 +1392,18 @@
           <a:p>
             <a:fld id="{C1FF6DA9-008F-8B48-92A6-B652298478BF}" type="slidenum">
               <a:rPr lang="en-US" smtClean="0"/>
+              <a:t>‹#›</a:t>
             </a:fld>
             <a:endParaRPr lang="en-US"/>
           </a:p>
         </p:txBody>
       </p:sp>
     </p:spTree>
+    <p:extLst>
+      <p:ext uri="{BB962C8B-B14F-4D97-AF65-F5344CB8AC3E}">
+        <p14:creationId xmlns:p14="http://schemas.microsoft.com/office/powerpoint/2010/main" val="2782244947"/>
+      </p:ext>
+    </p:extLst>
   </p:cSld>
   <p:clrMapOvr>
     <a:masterClrMapping/>
@@ -1512,7 +1517,6 @@
               <a:rPr lang="en-US" smtClean="0"/>
               <a:t>Click to edit Master text styles</a:t>
             </a:r>
-            <a:endParaRPr lang="en-US" smtClean="0"/>
           </a:p>
         </p:txBody>
       </p:sp>
@@ -1569,7 +1573,6 @@
               <a:rPr lang="en-US" smtClean="0"/>
               <a:t>Click to edit Master text styles</a:t>
             </a:r>
-            <a:endParaRPr lang="en-US" smtClean="0"/>
           </a:p>
           <a:p>
             <a:pPr lvl="1"/>
@@ -1577,7 +1580,6 @@
               <a:rPr lang="en-US" smtClean="0"/>
               <a:t>Second level</a:t>
             </a:r>
-            <a:endParaRPr lang="en-US" smtClean="0"/>
           </a:p>
           <a:p>
             <a:pPr lvl="2"/>
@@ -1585,7 +1587,6 @@
               <a:rPr lang="en-US" smtClean="0"/>
               <a:t>Third level</a:t>
             </a:r>
-            <a:endParaRPr lang="en-US" smtClean="0"/>
           </a:p>
           <a:p>
             <a:pPr lvl="3"/>
@@ -1593,7 +1594,6 @@
               <a:rPr lang="en-US" smtClean="0"/>
               <a:t>Fourth level</a:t>
             </a:r>
-            <a:endParaRPr lang="en-US" smtClean="0"/>
           </a:p>
           <a:p>
             <a:pPr lvl="4"/>
@@ -1667,7 +1667,6 @@
               <a:rPr lang="en-US" smtClean="0"/>
               <a:t>Click to edit Master text styles</a:t>
             </a:r>
-            <a:endParaRPr lang="en-US" smtClean="0"/>
           </a:p>
         </p:txBody>
       </p:sp>
@@ -1724,7 +1723,6 @@
               <a:rPr lang="en-US" smtClean="0"/>
               <a:t>Click to edit Master text styles</a:t>
             </a:r>
-            <a:endParaRPr lang="en-US" smtClean="0"/>
           </a:p>
           <a:p>
             <a:pPr lvl="1"/>
@@ -1732,7 +1730,6 @@
               <a:rPr lang="en-US" smtClean="0"/>
               <a:t>Second level</a:t>
             </a:r>
-            <a:endParaRPr lang="en-US" smtClean="0"/>
           </a:p>
           <a:p>
             <a:pPr lvl="2"/>
@@ -1740,7 +1737,6 @@
               <a:rPr lang="en-US" smtClean="0"/>
               <a:t>Third level</a:t>
             </a:r>
-            <a:endParaRPr lang="en-US" smtClean="0"/>
           </a:p>
           <a:p>
             <a:pPr lvl="3"/>
@@ -1748,7 +1744,6 @@
               <a:rPr lang="en-US" smtClean="0"/>
               <a:t>Fourth level</a:t>
             </a:r>
-            <a:endParaRPr lang="en-US" smtClean="0"/>
           </a:p>
           <a:p>
             <a:pPr lvl="4"/>
@@ -1777,6 +1772,7 @@
           <a:p>
             <a:fld id="{5BCAD085-E8A6-8845-BD4E-CB4CCA059FC4}" type="datetimeFigureOut">
               <a:rPr lang="en-US" smtClean="0"/>
+              <a:t>1/27/13</a:t>
             </a:fld>
             <a:endParaRPr lang="en-US"/>
           </a:p>
@@ -1818,12 +1814,18 @@
           <a:p>
             <a:fld id="{C1FF6DA9-008F-8B48-92A6-B652298478BF}" type="slidenum">
               <a:rPr lang="en-US" smtClean="0"/>
+              <a:t>‹#›</a:t>
             </a:fld>
             <a:endParaRPr lang="en-US"/>
           </a:p>
         </p:txBody>
       </p:sp>
     </p:spTree>
+    <p:extLst>
+      <p:ext uri="{BB962C8B-B14F-4D97-AF65-F5344CB8AC3E}">
+        <p14:creationId xmlns:p14="http://schemas.microsoft.com/office/powerpoint/2010/main" val="990158736"/>
+      </p:ext>
+    </p:extLst>
   </p:cSld>
   <p:clrMapOvr>
     <a:masterClrMapping/>
@@ -1888,6 +1890,7 @@
           <a:p>
             <a:fld id="{5BCAD085-E8A6-8845-BD4E-CB4CCA059FC4}" type="datetimeFigureOut">
               <a:rPr lang="en-US" smtClean="0"/>
+              <a:t>1/27/13</a:t>
             </a:fld>
             <a:endParaRPr lang="en-US"/>
           </a:p>
@@ -1929,12 +1932,18 @@
           <a:p>
             <a:fld id="{C1FF6DA9-008F-8B48-92A6-B652298478BF}" type="slidenum">
               <a:rPr lang="en-US" smtClean="0"/>
+              <a:t>‹#›</a:t>
             </a:fld>
             <a:endParaRPr lang="en-US"/>
           </a:p>
         </p:txBody>
       </p:sp>
     </p:spTree>
+    <p:extLst>
+      <p:ext uri="{BB962C8B-B14F-4D97-AF65-F5344CB8AC3E}">
+        <p14:creationId xmlns:p14="http://schemas.microsoft.com/office/powerpoint/2010/main" val="727027711"/>
+      </p:ext>
+    </p:extLst>
   </p:cSld>
   <p:clrMapOvr>
     <a:masterClrMapping/>
@@ -1976,6 +1985,7 @@
           <a:p>
             <a:fld id="{5BCAD085-E8A6-8845-BD4E-CB4CCA059FC4}" type="datetimeFigureOut">
               <a:rPr lang="en-US" smtClean="0"/>
+              <a:t>1/27/13</a:t>
             </a:fld>
             <a:endParaRPr lang="en-US"/>
           </a:p>
@@ -2017,12 +2027,18 @@
           <a:p>
             <a:fld id="{C1FF6DA9-008F-8B48-92A6-B652298478BF}" type="slidenum">
               <a:rPr lang="en-US" smtClean="0"/>
+              <a:t>‹#›</a:t>
             </a:fld>
             <a:endParaRPr lang="en-US"/>
           </a:p>
         </p:txBody>
       </p:sp>
     </p:spTree>
+    <p:extLst>
+      <p:ext uri="{BB962C8B-B14F-4D97-AF65-F5344CB8AC3E}">
+        <p14:creationId xmlns:p14="http://schemas.microsoft.com/office/powerpoint/2010/main" val="1212999818"/>
+      </p:ext>
+    </p:extLst>
   </p:cSld>
   <p:clrMapOvr>
     <a:masterClrMapping/>
@@ -2132,7 +2148,6 @@
               <a:rPr lang="en-US" smtClean="0"/>
               <a:t>Click to edit Master text styles</a:t>
             </a:r>
-            <a:endParaRPr lang="en-US" smtClean="0"/>
           </a:p>
           <a:p>
             <a:pPr lvl="1"/>
@@ -2140,7 +2155,6 @@
               <a:rPr lang="en-US" smtClean="0"/>
               <a:t>Second level</a:t>
             </a:r>
-            <a:endParaRPr lang="en-US" smtClean="0"/>
           </a:p>
           <a:p>
             <a:pPr lvl="2"/>
@@ -2148,7 +2162,6 @@
               <a:rPr lang="en-US" smtClean="0"/>
               <a:t>Third level</a:t>
             </a:r>
-            <a:endParaRPr lang="en-US" smtClean="0"/>
           </a:p>
           <a:p>
             <a:pPr lvl="3"/>
@@ -2156,7 +2169,6 @@
               <a:rPr lang="en-US" smtClean="0"/>
               <a:t>Fourth level</a:t>
             </a:r>
-            <a:endParaRPr lang="en-US" smtClean="0"/>
           </a:p>
           <a:p>
             <a:pPr lvl="4"/>
@@ -2230,7 +2242,6 @@
               <a:rPr lang="en-US" smtClean="0"/>
               <a:t>Click to edit Master text styles</a:t>
             </a:r>
-            <a:endParaRPr lang="en-US" smtClean="0"/>
           </a:p>
         </p:txBody>
       </p:sp>
@@ -2251,6 +2262,7 @@
           <a:p>
             <a:fld id="{5BCAD085-E8A6-8845-BD4E-CB4CCA059FC4}" type="datetimeFigureOut">
               <a:rPr lang="en-US" smtClean="0"/>
+              <a:t>1/27/13</a:t>
             </a:fld>
             <a:endParaRPr lang="en-US"/>
           </a:p>
@@ -2292,12 +2304,18 @@
           <a:p>
             <a:fld id="{C1FF6DA9-008F-8B48-92A6-B652298478BF}" type="slidenum">
               <a:rPr lang="en-US" smtClean="0"/>
+              <a:t>‹#›</a:t>
             </a:fld>
             <a:endParaRPr lang="en-US"/>
           </a:p>
         </p:txBody>
       </p:sp>
     </p:spTree>
+    <p:extLst>
+      <p:ext uri="{BB962C8B-B14F-4D97-AF65-F5344CB8AC3E}">
+        <p14:creationId xmlns:p14="http://schemas.microsoft.com/office/powerpoint/2010/main" val="1840726560"/>
+      </p:ext>
+    </p:extLst>
   </p:cSld>
   <p:clrMapOvr>
     <a:masterClrMapping/>
@@ -2477,7 +2495,6 @@
               <a:rPr lang="en-US" smtClean="0"/>
               <a:t>Click to edit Master text styles</a:t>
             </a:r>
-            <a:endParaRPr lang="en-US" smtClean="0"/>
           </a:p>
         </p:txBody>
       </p:sp>
@@ -2498,6 +2515,7 @@
           <a:p>
             <a:fld id="{5BCAD085-E8A6-8845-BD4E-CB4CCA059FC4}" type="datetimeFigureOut">
               <a:rPr lang="en-US" smtClean="0"/>
+              <a:t>1/27/13</a:t>
             </a:fld>
             <a:endParaRPr lang="en-US"/>
           </a:p>
@@ -2539,12 +2557,18 @@
           <a:p>
             <a:fld id="{C1FF6DA9-008F-8B48-92A6-B652298478BF}" type="slidenum">
               <a:rPr lang="en-US" smtClean="0"/>
+              <a:t>‹#›</a:t>
             </a:fld>
             <a:endParaRPr lang="en-US"/>
           </a:p>
         </p:txBody>
       </p:sp>
     </p:spTree>
+    <p:extLst>
+      <p:ext uri="{BB962C8B-B14F-4D97-AF65-F5344CB8AC3E}">
+        <p14:creationId xmlns:p14="http://schemas.microsoft.com/office/powerpoint/2010/main" val="3889236939"/>
+      </p:ext>
+    </p:extLst>
   </p:cSld>
   <p:clrMapOvr>
     <a:masterClrMapping/>
@@ -2637,7 +2661,6 @@
               <a:rPr lang="en-US" smtClean="0"/>
               <a:t>Click to edit Master text styles</a:t>
             </a:r>
-            <a:endParaRPr lang="en-US" smtClean="0"/>
           </a:p>
           <a:p>
             <a:pPr lvl="1"/>
@@ -2645,7 +2668,6 @@
               <a:rPr lang="en-US" smtClean="0"/>
               <a:t>Second level</a:t>
             </a:r>
-            <a:endParaRPr lang="en-US" smtClean="0"/>
           </a:p>
           <a:p>
             <a:pPr lvl="2"/>
@@ -2653,7 +2675,6 @@
               <a:rPr lang="en-US" smtClean="0"/>
               <a:t>Third level</a:t>
             </a:r>
-            <a:endParaRPr lang="en-US" smtClean="0"/>
           </a:p>
           <a:p>
             <a:pPr lvl="3"/>
@@ -2661,7 +2682,6 @@
               <a:rPr lang="en-US" smtClean="0"/>
               <a:t>Fourth level</a:t>
             </a:r>
-            <a:endParaRPr lang="en-US" smtClean="0"/>
           </a:p>
           <a:p>
             <a:pPr lvl="4"/>
@@ -2708,6 +2728,7 @@
           <a:p>
             <a:fld id="{5BCAD085-E8A6-8845-BD4E-CB4CCA059FC4}" type="datetimeFigureOut">
               <a:rPr lang="en-US" smtClean="0"/>
+              <a:t>1/27/13</a:t>
             </a:fld>
             <a:endParaRPr lang="en-US"/>
           </a:p>
@@ -2785,12 +2806,18 @@
           <a:p>
             <a:fld id="{C1FF6DA9-008F-8B48-92A6-B652298478BF}" type="slidenum">
               <a:rPr lang="en-US" smtClean="0"/>
+              <a:t>‹#›</a:t>
             </a:fld>
             <a:endParaRPr lang="en-US"/>
           </a:p>
         </p:txBody>
       </p:sp>
     </p:spTree>
+    <p:extLst>
+      <p:ext uri="{BB962C8B-B14F-4D97-AF65-F5344CB8AC3E}">
+        <p14:creationId xmlns:p14="http://schemas.microsoft.com/office/powerpoint/2010/main" val="2209977519"/>
+      </p:ext>
+    </p:extLst>
   </p:cSld>
   <p:clrMap bg1="lt1" tx1="dk1" bg2="lt2" tx2="dk2" accent1="accent1" accent2="accent2" accent3="accent3" accent4="accent4" accent5="accent5" accent6="accent6" hlink="hlink" folHlink="folHlink"/>
   <p:sldLayoutIdLst>
@@ -2828,7 +2855,7 @@
         <a:spcBef>
           <a:spcPct val="20000"/>
         </a:spcBef>
-        <a:buFont typeface="Arial" panose="020B0604020202020204"/>
+        <a:buFont typeface="Arial"/>
         <a:buChar char="•"/>
         <a:defRPr sz="3200" kern="1200">
           <a:solidFill>
@@ -2843,7 +2870,7 @@
         <a:spcBef>
           <a:spcPct val="20000"/>
         </a:spcBef>
-        <a:buFont typeface="Arial" panose="020B0604020202020204"/>
+        <a:buFont typeface="Arial"/>
         <a:buChar char="–"/>
         <a:defRPr sz="2800" kern="1200">
           <a:solidFill>
@@ -2858,7 +2885,7 @@
         <a:spcBef>
           <a:spcPct val="20000"/>
         </a:spcBef>
-        <a:buFont typeface="Arial" panose="020B0604020202020204"/>
+        <a:buFont typeface="Arial"/>
         <a:buChar char="•"/>
         <a:defRPr sz="2400" kern="1200">
           <a:solidFill>
@@ -2873,7 +2900,7 @@
         <a:spcBef>
           <a:spcPct val="20000"/>
         </a:spcBef>
-        <a:buFont typeface="Arial" panose="020B0604020202020204"/>
+        <a:buFont typeface="Arial"/>
         <a:buChar char="–"/>
         <a:defRPr sz="2000" kern="1200">
           <a:solidFill>
@@ -2888,7 +2915,7 @@
         <a:spcBef>
           <a:spcPct val="20000"/>
         </a:spcBef>
-        <a:buFont typeface="Arial" panose="020B0604020202020204"/>
+        <a:buFont typeface="Arial"/>
         <a:buChar char="»"/>
         <a:defRPr sz="2000" kern="1200">
           <a:solidFill>
@@ -2903,7 +2930,7 @@
         <a:spcBef>
           <a:spcPct val="20000"/>
         </a:spcBef>
-        <a:buFont typeface="Arial" panose="020B0604020202020204"/>
+        <a:buFont typeface="Arial"/>
         <a:buChar char="•"/>
         <a:defRPr sz="2000" kern="1200">
           <a:solidFill>
@@ -2918,7 +2945,7 @@
         <a:spcBef>
           <a:spcPct val="20000"/>
         </a:spcBef>
-        <a:buFont typeface="Arial" panose="020B0604020202020204"/>
+        <a:buFont typeface="Arial"/>
         <a:buChar char="•"/>
         <a:defRPr sz="2000" kern="1200">
           <a:solidFill>
@@ -2933,7 +2960,7 @@
         <a:spcBef>
           <a:spcPct val="20000"/>
         </a:spcBef>
-        <a:buFont typeface="Arial" panose="020B0604020202020204"/>
+        <a:buFont typeface="Arial"/>
         <a:buChar char="•"/>
         <a:defRPr sz="2000" kern="1200">
           <a:solidFill>
@@ -2948,7 +2975,7 @@
         <a:spcBef>
           <a:spcPct val="20000"/>
         </a:spcBef>
-        <a:buFont typeface="Arial" panose="020B0604020202020204"/>
+        <a:buFont typeface="Arial"/>
         <a:buChar char="•"/>
         <a:defRPr sz="2000" kern="1200">
           <a:solidFill>
@@ -3060,7 +3087,7 @@
 </file>
 
 <file path=ppt/slides/slide1.xml><?xml version="1.0" encoding="utf-8"?>
-<p:sld xmlns:a="http://schemas.openxmlformats.org/drawingml/2006/main" xmlns:r="http://schemas.openxmlformats.org/officeDocument/2006/relationships" xmlns:p="http://schemas.openxmlformats.org/presentationml/2006/main">
+<p:sld xmlns:a="http://schemas.openxmlformats.org/drawingml/2006/main" xmlns:p="http://schemas.openxmlformats.org/presentationml/2006/main" xmlns:r="http://schemas.openxmlformats.org/officeDocument/2006/relationships">
   <p:cSld>
     <p:bg>
       <p:bgPr>
@@ -3079,14 +3106,14 @@
       <p:grpSpPr/>
       <p:pic>
         <p:nvPicPr>
-          <p:cNvPr id="2" name="Picture 1" descr="paper_texture.png"/>
+          <p:cNvPr id="2" name="Picture 1" descr="rice_paper_bg.png"/>
           <p:cNvPicPr>
             <a:picLocks noChangeAspect="1"/>
           </p:cNvPicPr>
           <p:nvPr/>
         </p:nvPicPr>
         <p:blipFill>
-          <a:blip r:embed="rId1"/>
+          <a:blip r:embed="rId2"/>
           <a:stretch>
             <a:fillRect/>
           </a:stretch>
@@ -3145,9 +3172,33 @@
           </a:p>
         </p:txBody>
       </p:sp>
-      <p:sp>
-        <p:nvSpPr>
-          <p:cNvPr id="4" name="Rectangle 3"/>
+      <p:pic>
+        <p:nvPicPr>
+          <p:cNvPr id="4" name="Picture 3" descr="cloud.png"/>
+          <p:cNvPicPr>
+            <a:picLocks noChangeAspect="1"/>
+          </p:cNvPicPr>
+          <p:nvPr/>
+        </p:nvPicPr>
+        <p:blipFill>
+          <a:blip r:embed="rId3"/>
+          <a:stretch>
+            <a:fillRect/>
+          </a:stretch>
+        </p:blipFill>
+        <p:spPr>
+          <a:xfrm>
+            <a:off x="91440" y="457200"/>
+            <a:ext cx="4023360" cy="1181603"/>
+          </a:xfrm>
+          <a:prstGeom prst="rect">
+            <a:avLst/>
+          </a:prstGeom>
+        </p:spPr>
+      </p:pic>
+      <p:sp>
+        <p:nvSpPr>
+          <p:cNvPr id="5" name="Rectangle 4"/>
           <p:cNvSpPr/>
           <p:nvPr/>
         </p:nvSpPr>
@@ -3191,7 +3242,7 @@
       </p:sp>
       <p:sp>
         <p:nvSpPr>
-          <p:cNvPr id="5" name="TextBox 4"/>
+          <p:cNvPr id="6" name="TextBox 5"/>
           <p:cNvSpPr txBox="1"/>
           <p:nvPr/>
         </p:nvSpPr>
@@ -3227,18 +3278,11 @@
                 <a:solidFill>
                   <a:srgbClr val="FFFBF0"/>
                 </a:solidFill>
-                <a:latin typeface="宋体" panose="02010600030101010101" pitchFamily="2" charset="-122"/>
-                <a:ea typeface="宋体" panose="02010600030101010101" pitchFamily="2" charset="-122"/>
+                <a:latin typeface="宋体"/>
+                <a:ea typeface="宋体"/>
               </a:rPr>
               <a:t>设</a:t>
             </a:r>
-            <a:endParaRPr sz="5400" b="1" i="0">
-              <a:solidFill>
-                <a:srgbClr val="FFFBF0"/>
-              </a:solidFill>
-              <a:latin typeface="宋体" panose="02010600030101010101" pitchFamily="2" charset="-122"/>
-              <a:ea typeface="宋体" panose="02010600030101010101" pitchFamily="2" charset="-122"/>
-            </a:endParaRPr>
           </a:p>
           <a:p>
             <a:pPr algn="l">
@@ -3257,18 +3301,11 @@
                 <a:solidFill>
                   <a:srgbClr val="FFFBF0"/>
                 </a:solidFill>
-                <a:latin typeface="宋体" panose="02010600030101010101" pitchFamily="2" charset="-122"/>
-                <a:ea typeface="宋体" panose="02010600030101010101" pitchFamily="2" charset="-122"/>
+                <a:latin typeface="宋体"/>
+                <a:ea typeface="宋体"/>
               </a:rPr>
               <a:t>计</a:t>
             </a:r>
-            <a:endParaRPr sz="5400" b="1" i="0">
-              <a:solidFill>
-                <a:srgbClr val="FFFBF0"/>
-              </a:solidFill>
-              <a:latin typeface="宋体" panose="02010600030101010101" pitchFamily="2" charset="-122"/>
-              <a:ea typeface="宋体" panose="02010600030101010101" pitchFamily="2" charset="-122"/>
-            </a:endParaRPr>
           </a:p>
           <a:p>
             <a:pPr algn="l">
@@ -3287,18 +3324,11 @@
                 <a:solidFill>
                   <a:srgbClr val="FFFBF0"/>
                 </a:solidFill>
-                <a:latin typeface="宋体" panose="02010600030101010101" pitchFamily="2" charset="-122"/>
-                <a:ea typeface="宋体" panose="02010600030101010101" pitchFamily="2" charset="-122"/>
+                <a:latin typeface="宋体"/>
+                <a:ea typeface="宋体"/>
               </a:rPr>
               <a:t>初</a:t>
             </a:r>
-            <a:endParaRPr sz="5400" b="1" i="0">
-              <a:solidFill>
-                <a:srgbClr val="FFFBF0"/>
-              </a:solidFill>
-              <a:latin typeface="宋体" panose="02010600030101010101" pitchFamily="2" charset="-122"/>
-              <a:ea typeface="宋体" panose="02010600030101010101" pitchFamily="2" charset="-122"/>
-            </a:endParaRPr>
           </a:p>
           <a:p>
             <a:pPr algn="l">
@@ -3317,24 +3347,17 @@
                 <a:solidFill>
                   <a:srgbClr val="FFFBF0"/>
                 </a:solidFill>
-                <a:latin typeface="宋体" panose="02010600030101010101" pitchFamily="2" charset="-122"/>
-                <a:ea typeface="宋体" panose="02010600030101010101" pitchFamily="2" charset="-122"/>
+                <a:latin typeface="宋体"/>
+                <a:ea typeface="宋体"/>
               </a:rPr>
               <a:t>稿</a:t>
             </a:r>
-            <a:endParaRPr sz="5400" b="1" i="0">
-              <a:solidFill>
-                <a:srgbClr val="FFFBF0"/>
-              </a:solidFill>
-              <a:latin typeface="宋体" panose="02010600030101010101" pitchFamily="2" charset="-122"/>
-              <a:ea typeface="宋体" panose="02010600030101010101" pitchFamily="2" charset="-122"/>
-            </a:endParaRPr>
-          </a:p>
-        </p:txBody>
-      </p:sp>
-      <p:sp>
-        <p:nvSpPr>
-          <p:cNvPr id="6" name="Oval 5"/>
+          </a:p>
+        </p:txBody>
+      </p:sp>
+      <p:sp>
+        <p:nvSpPr>
+          <p:cNvPr id="7" name="Oval 6"/>
           <p:cNvSpPr/>
           <p:nvPr/>
         </p:nvSpPr>
@@ -3378,13 +3401,13 @@
       </p:sp>
       <p:sp>
         <p:nvSpPr>
-          <p:cNvPr id="7" name="TextBox 6"/>
+          <p:cNvPr id="8" name="TextBox 7"/>
           <p:cNvSpPr txBox="1"/>
           <p:nvPr/>
         </p:nvSpPr>
         <p:spPr>
           <a:xfrm>
-            <a:off x="484632" y="5504688"/>
+            <a:off x="804672" y="5504688"/>
             <a:ext cx="914400" cy="457200"/>
           </a:xfrm>
           <a:prstGeom prst="rect">
@@ -3414,24 +3437,41 @@
                 <a:solidFill>
                   <a:srgbClr val="FFFBF0"/>
                 </a:solidFill>
-                <a:latin typeface="楷体" panose="02010609060101010101" charset="-122"/>
-                <a:ea typeface="楷体" panose="02010609060101010101" charset="-122"/>
+                <a:latin typeface="楷体"/>
+                <a:ea typeface="楷体"/>
               </a:rPr>
               <a:t>匠</a:t>
             </a:r>
-            <a:endParaRPr sz="1700" b="1" i="0">
-              <a:solidFill>
-                <a:srgbClr val="FFFBF0"/>
-              </a:solidFill>
-              <a:latin typeface="楷体" panose="02010609060101010101" charset="-122"/>
-              <a:ea typeface="楷体" panose="02010609060101010101" charset="-122"/>
-            </a:endParaRPr>
-          </a:p>
-        </p:txBody>
-      </p:sp>
-      <p:sp>
-        <p:nvSpPr>
-          <p:cNvPr id="8" name="TextBox 7"/>
+          </a:p>
+        </p:txBody>
+      </p:sp>
+      <p:pic>
+        <p:nvPicPr>
+          <p:cNvPr id="9" name="Picture 8" descr="coin.png"/>
+          <p:cNvPicPr>
+            <a:picLocks noChangeAspect="1"/>
+          </p:cNvPicPr>
+          <p:nvPr/>
+        </p:nvPicPr>
+        <p:blipFill>
+          <a:blip r:embed="rId4"/>
+          <a:stretch>
+            <a:fillRect/>
+          </a:stretch>
+        </p:blipFill>
+        <p:spPr>
+          <a:xfrm>
+            <a:off x="10927080" y="566928"/>
+            <a:ext cx="841248" cy="841248"/>
+          </a:xfrm>
+          <a:prstGeom prst="rect">
+            <a:avLst/>
+          </a:prstGeom>
+        </p:spPr>
+      </p:pic>
+      <p:sp>
+        <p:nvSpPr>
+          <p:cNvPr id="10" name="TextBox 9"/>
           <p:cNvSpPr txBox="1"/>
           <p:nvPr/>
         </p:nvSpPr>
@@ -3467,18 +3507,11 @@
                 <a:solidFill>
                   <a:srgbClr val="065279"/>
                 </a:solidFill>
-                <a:latin typeface="微软雅黑" panose="020B0503020204020204" charset="-122"/>
-                <a:ea typeface="微软雅黑" panose="020B0503020204020204" charset="-122"/>
+                <a:latin typeface="微软雅黑"/>
+                <a:ea typeface="微软雅黑"/>
               </a:rPr>
               <a:t>AI Agent + Skill</a:t>
             </a:r>
-            <a:endParaRPr sz="3300" b="1" i="0">
-              <a:solidFill>
-                <a:srgbClr val="065279"/>
-              </a:solidFill>
-              <a:latin typeface="微软雅黑" panose="020B0503020204020204" charset="-122"/>
-              <a:ea typeface="微软雅黑" panose="020B0503020204020204" charset="-122"/>
-            </a:endParaRPr>
           </a:p>
           <a:p>
             <a:pPr algn="l">
@@ -3497,24 +3530,17 @@
                 <a:solidFill>
                   <a:srgbClr val="161823"/>
                 </a:solidFill>
-                <a:latin typeface="宋体" panose="02010600030101010101" pitchFamily="2" charset="-122"/>
-                <a:ea typeface="宋体" panose="02010600030101010101" pitchFamily="2" charset="-122"/>
+                <a:latin typeface="宋体"/>
+                <a:ea typeface="宋体"/>
               </a:rPr>
               <a:t>设计工作流指南</a:t>
             </a:r>
-            <a:endParaRPr sz="4000" b="1" i="0">
-              <a:solidFill>
-                <a:srgbClr val="161823"/>
-              </a:solidFill>
-              <a:latin typeface="宋体" panose="02010600030101010101" pitchFamily="2" charset="-122"/>
-              <a:ea typeface="宋体" panose="02010600030101010101" pitchFamily="2" charset="-122"/>
-            </a:endParaRPr>
           </a:p>
         </p:txBody>
       </p:sp>
       <p:cxnSp>
         <p:nvCxnSpPr>
-          <p:cNvPr id="9" name="Connector 8"/>
+          <p:cNvPr id="11" name="Connector 10"/>
           <p:cNvCxnSpPr/>
           <p:nvPr/>
         </p:nvCxnSpPr>
@@ -3550,7 +3576,7 @@
       </p:cxnSp>
       <p:sp>
         <p:nvSpPr>
-          <p:cNvPr id="10" name="TextBox 9"/>
+          <p:cNvPr id="12" name="TextBox 11"/>
           <p:cNvSpPr txBox="1"/>
           <p:nvPr/>
         </p:nvSpPr>
@@ -3586,18 +3612,11 @@
                 <a:solidFill>
                   <a:srgbClr val="50616D"/>
                 </a:solidFill>
-                <a:latin typeface="微软雅黑" panose="020B0503020204020204" charset="-122"/>
-                <a:ea typeface="微软雅黑" panose="020B0503020204020204" charset="-122"/>
+                <a:latin typeface="微软雅黑"/>
+                <a:ea typeface="微软雅黑"/>
               </a:rPr>
               <a:t>用 大模型 + 技能 + 工具 生成「可用且美观」的设计与科研初稿</a:t>
             </a:r>
-            <a:endParaRPr sz="1550" b="0" i="0">
-              <a:solidFill>
-                <a:srgbClr val="50616D"/>
-              </a:solidFill>
-              <a:latin typeface="微软雅黑" panose="020B0503020204020204" charset="-122"/>
-              <a:ea typeface="微软雅黑" panose="020B0503020204020204" charset="-122"/>
-            </a:endParaRPr>
           </a:p>
           <a:p>
             <a:pPr algn="l">
@@ -3616,24 +3635,17 @@
                 <a:solidFill>
                   <a:srgbClr val="50616D"/>
                 </a:solidFill>
-                <a:latin typeface="微软雅黑" panose="020B0503020204020204" charset="-122"/>
-                <a:ea typeface="微软雅黑" panose="020B0503020204020204" charset="-122"/>
+                <a:latin typeface="微软雅黑"/>
+                <a:ea typeface="微软雅黑"/>
               </a:rPr>
               <a:t>PPT · 科研绘图 · SVG · 海报 — 以 my-design-style 中国传统色风格演示</a:t>
             </a:r>
-            <a:endParaRPr sz="1300" b="0" i="0">
-              <a:solidFill>
-                <a:srgbClr val="50616D"/>
-              </a:solidFill>
-              <a:latin typeface="微软雅黑" panose="020B0503020204020204" charset="-122"/>
-              <a:ea typeface="微软雅黑" panose="020B0503020204020204" charset="-122"/>
-            </a:endParaRPr>
-          </a:p>
-        </p:txBody>
-      </p:sp>
-      <p:sp>
-        <p:nvSpPr>
-          <p:cNvPr id="11" name="TextBox 10"/>
+          </a:p>
+        </p:txBody>
+      </p:sp>
+      <p:sp>
+        <p:nvSpPr>
+          <p:cNvPr id="13" name="TextBox 12"/>
           <p:cNvSpPr txBox="1"/>
           <p:nvPr/>
         </p:nvSpPr>
@@ -3669,18 +3681,11 @@
                 <a:solidFill>
                   <a:srgbClr val="177CB0"/>
                 </a:solidFill>
-                <a:latin typeface="微软雅黑" panose="020B0503020204020204" charset="-122"/>
-                <a:ea typeface="微软雅黑" panose="020B0503020204020204" charset="-122"/>
+                <a:latin typeface="微软雅黑"/>
+                <a:ea typeface="微软雅黑"/>
               </a:rPr>
               <a:t>chinese_traditional_color_style  ·  靛青学者 × 墨纸  ·  2026</a:t>
             </a:r>
-            <a:endParaRPr sz="1150" b="0" i="0">
-              <a:solidFill>
-                <a:srgbClr val="177CB0"/>
-              </a:solidFill>
-              <a:latin typeface="微软雅黑" panose="020B0503020204020204" charset="-122"/>
-              <a:ea typeface="微软雅黑" panose="020B0503020204020204" charset="-122"/>
-            </a:endParaRPr>
           </a:p>
         </p:txBody>
       </p:sp>
@@ -3693,7 +3698,7 @@
 </file>
 
 <file path=ppt/slides/slide2.xml><?xml version="1.0" encoding="utf-8"?>
-<p:sld xmlns:a="http://schemas.openxmlformats.org/drawingml/2006/main" xmlns:r="http://schemas.openxmlformats.org/officeDocument/2006/relationships" xmlns:p="http://schemas.openxmlformats.org/presentationml/2006/main">
+<p:sld xmlns:a="http://schemas.openxmlformats.org/drawingml/2006/main" xmlns:p="http://schemas.openxmlformats.org/presentationml/2006/main" xmlns:r="http://schemas.openxmlformats.org/officeDocument/2006/relationships">
   <p:cSld>
     <p:bg>
       <p:bgPr>
@@ -3712,14 +3717,14 @@
       <p:grpSpPr/>
       <p:pic>
         <p:nvPicPr>
-          <p:cNvPr id="2" name="Picture 1" descr="paper_texture.png"/>
+          <p:cNvPr id="2" name="Picture 1" descr="rice_paper_bg.png"/>
           <p:cNvPicPr>
             <a:picLocks noChangeAspect="1"/>
           </p:cNvPicPr>
           <p:nvPr/>
         </p:nvPicPr>
         <p:blipFill>
-          <a:blip r:embed="rId1"/>
+          <a:blip r:embed="rId2"/>
           <a:stretch>
             <a:fillRect/>
           </a:stretch>
@@ -3830,7 +3835,7 @@
         </p:nvSpPr>
         <p:spPr>
           <a:xfrm>
-            <a:off x="475615" y="621919"/>
+            <a:off x="640080" y="603504"/>
             <a:ext cx="548640" cy="457200"/>
           </a:xfrm>
           <a:prstGeom prst="rect">
@@ -3860,18 +3865,11 @@
                 <a:solidFill>
                   <a:srgbClr val="FFFBF0"/>
                 </a:solidFill>
-                <a:latin typeface="宋体" panose="02010600030101010101" pitchFamily="2" charset="-122"/>
-                <a:ea typeface="宋体" panose="02010600030101010101" pitchFamily="2" charset="-122"/>
+                <a:latin typeface="宋体"/>
+                <a:ea typeface="宋体"/>
               </a:rPr>
               <a:t>色</a:t>
             </a:r>
-            <a:endParaRPr sz="1500" b="1" i="0">
-              <a:solidFill>
-                <a:srgbClr val="FFFBF0"/>
-              </a:solidFill>
-              <a:latin typeface="宋体" panose="02010600030101010101" pitchFamily="2" charset="-122"/>
-              <a:ea typeface="宋体" panose="02010600030101010101" pitchFamily="2" charset="-122"/>
-            </a:endParaRPr>
           </a:p>
         </p:txBody>
       </p:sp>
@@ -3913,18 +3911,11 @@
                 <a:solidFill>
                   <a:srgbClr val="161823"/>
                 </a:solidFill>
-                <a:latin typeface="宋体" panose="02010600030101010101" pitchFamily="2" charset="-122"/>
-                <a:ea typeface="宋体" panose="02010600030101010101" pitchFamily="2" charset="-122"/>
+                <a:latin typeface="宋体"/>
+                <a:ea typeface="宋体"/>
               </a:rPr>
               <a:t>选用色卡 · 靛青学者 + 墨纸</a:t>
             </a:r>
-            <a:endParaRPr sz="2700" b="1" i="0">
-              <a:solidFill>
-                <a:srgbClr val="161823"/>
-              </a:solidFill>
-              <a:latin typeface="宋体" panose="02010600030101010101" pitchFamily="2" charset="-122"/>
-              <a:ea typeface="宋体" panose="02010600030101010101" pitchFamily="2" charset="-122"/>
-            </a:endParaRPr>
           </a:p>
         </p:txBody>
       </p:sp>
@@ -3966,18 +3957,11 @@
                 <a:solidFill>
                   <a:srgbClr val="177CB0"/>
                 </a:solidFill>
-                <a:latin typeface="微软雅黑" panose="020B0503020204020204" charset="-122"/>
-                <a:ea typeface="微软雅黑" panose="020B0503020204020204" charset="-122"/>
+                <a:latin typeface="微软雅黑"/>
+                <a:ea typeface="微软雅黑"/>
               </a:rPr>
               <a:t>COLOR LEGEND — Indigo Scholarly × Ink Paper</a:t>
             </a:r>
-            <a:endParaRPr sz="1200" b="0" i="0">
-              <a:solidFill>
-                <a:srgbClr val="177CB0"/>
-              </a:solidFill>
-              <a:latin typeface="微软雅黑" panose="020B0503020204020204" charset="-122"/>
-              <a:ea typeface="微软雅黑" panose="020B0503020204020204" charset="-122"/>
-            </a:endParaRPr>
           </a:p>
         </p:txBody>
       </p:sp>
@@ -4055,18 +4039,11 @@
                 <a:solidFill>
                   <a:srgbClr val="50616D"/>
                 </a:solidFill>
-                <a:latin typeface="微软雅黑" panose="020B0503020204020204" charset="-122"/>
-                <a:ea typeface="微软雅黑" panose="020B0503020204020204" charset="-122"/>
+                <a:latin typeface="微软雅黑"/>
+                <a:ea typeface="微软雅黑"/>
               </a:rPr>
               <a:t>全部取自《中国传统色》命名色，主色一张色卡贯穿全篇，墨纸作底，金色仅作点睛。</a:t>
             </a:r>
-            <a:endParaRPr sz="1350" b="0" i="0">
-              <a:solidFill>
-                <a:srgbClr val="50616D"/>
-              </a:solidFill>
-              <a:latin typeface="微软雅黑" panose="020B0503020204020204" charset="-122"/>
-              <a:ea typeface="微软雅黑" panose="020B0503020204020204" charset="-122"/>
-            </a:endParaRPr>
           </a:p>
         </p:txBody>
       </p:sp>
@@ -4152,18 +4129,11 @@
                 <a:solidFill>
                   <a:srgbClr val="FFFFFF"/>
                 </a:solidFill>
-                <a:latin typeface="宋体" panose="02010600030101010101" pitchFamily="2" charset="-122"/>
-                <a:ea typeface="宋体" panose="02010600030101010101" pitchFamily="2" charset="-122"/>
+                <a:latin typeface="宋体"/>
+                <a:ea typeface="宋体"/>
               </a:rPr>
               <a:t>靛青</a:t>
             </a:r>
-            <a:endParaRPr sz="1800" b="1" i="0">
-              <a:solidFill>
-                <a:srgbClr val="FFFFFF"/>
-              </a:solidFill>
-              <a:latin typeface="宋体" panose="02010600030101010101" pitchFamily="2" charset="-122"/>
-              <a:ea typeface="宋体" panose="02010600030101010101" pitchFamily="2" charset="-122"/>
-            </a:endParaRPr>
           </a:p>
           <a:p>
             <a:pPr algn="l">
@@ -4182,18 +4152,11 @@
                 <a:solidFill>
                   <a:srgbClr val="FFFFFF"/>
                 </a:solidFill>
-                <a:latin typeface="微软雅黑" panose="020B0503020204020204" charset="-122"/>
-                <a:ea typeface="微软雅黑" panose="020B0503020204020204" charset="-122"/>
+                <a:latin typeface="微软雅黑"/>
+                <a:ea typeface="微软雅黑"/>
               </a:rPr>
               <a:t>#177CB0</a:t>
             </a:r>
-            <a:endParaRPr sz="1050" b="0" i="0">
-              <a:solidFill>
-                <a:srgbClr val="FFFFFF"/>
-              </a:solidFill>
-              <a:latin typeface="微软雅黑" panose="020B0503020204020204" charset="-122"/>
-              <a:ea typeface="微软雅黑" panose="020B0503020204020204" charset="-122"/>
-            </a:endParaRPr>
           </a:p>
         </p:txBody>
       </p:sp>
@@ -4279,18 +4242,11 @@
                 <a:solidFill>
                   <a:srgbClr val="FFFFFF"/>
                 </a:solidFill>
-                <a:latin typeface="宋体" panose="02010600030101010101" pitchFamily="2" charset="-122"/>
-                <a:ea typeface="宋体" panose="02010600030101010101" pitchFamily="2" charset="-122"/>
+                <a:latin typeface="宋体"/>
+                <a:ea typeface="宋体"/>
               </a:rPr>
               <a:t>靛蓝</a:t>
             </a:r>
-            <a:endParaRPr sz="1800" b="1" i="0">
-              <a:solidFill>
-                <a:srgbClr val="FFFFFF"/>
-              </a:solidFill>
-              <a:latin typeface="宋体" panose="02010600030101010101" pitchFamily="2" charset="-122"/>
-              <a:ea typeface="宋体" panose="02010600030101010101" pitchFamily="2" charset="-122"/>
-            </a:endParaRPr>
           </a:p>
           <a:p>
             <a:pPr algn="l">
@@ -4309,18 +4265,11 @@
                 <a:solidFill>
                   <a:srgbClr val="FFFFFF"/>
                 </a:solidFill>
-                <a:latin typeface="微软雅黑" panose="020B0503020204020204" charset="-122"/>
-                <a:ea typeface="微软雅黑" panose="020B0503020204020204" charset="-122"/>
+                <a:latin typeface="微软雅黑"/>
+                <a:ea typeface="微软雅黑"/>
               </a:rPr>
               <a:t>#065279</a:t>
             </a:r>
-            <a:endParaRPr sz="1050" b="0" i="0">
-              <a:solidFill>
-                <a:srgbClr val="FFFFFF"/>
-              </a:solidFill>
-              <a:latin typeface="微软雅黑" panose="020B0503020204020204" charset="-122"/>
-              <a:ea typeface="微软雅黑" panose="020B0503020204020204" charset="-122"/>
-            </a:endParaRPr>
           </a:p>
         </p:txBody>
       </p:sp>
@@ -4406,18 +4355,11 @@
                 <a:solidFill>
                   <a:srgbClr val="161823"/>
                 </a:solidFill>
-                <a:latin typeface="宋体" panose="02010600030101010101" pitchFamily="2" charset="-122"/>
-                <a:ea typeface="宋体" panose="02010600030101010101" pitchFamily="2" charset="-122"/>
+                <a:latin typeface="宋体"/>
+                <a:ea typeface="宋体"/>
               </a:rPr>
               <a:t>蓝</a:t>
             </a:r>
-            <a:endParaRPr sz="1800" b="1" i="0">
-              <a:solidFill>
-                <a:srgbClr val="161823"/>
-              </a:solidFill>
-              <a:latin typeface="宋体" panose="02010600030101010101" pitchFamily="2" charset="-122"/>
-              <a:ea typeface="宋体" panose="02010600030101010101" pitchFamily="2" charset="-122"/>
-            </a:endParaRPr>
           </a:p>
           <a:p>
             <a:pPr algn="l">
@@ -4436,18 +4378,11 @@
                 <a:solidFill>
                   <a:srgbClr val="161823"/>
                 </a:solidFill>
-                <a:latin typeface="微软雅黑" panose="020B0503020204020204" charset="-122"/>
-                <a:ea typeface="微软雅黑" panose="020B0503020204020204" charset="-122"/>
+                <a:latin typeface="微软雅黑"/>
+                <a:ea typeface="微软雅黑"/>
               </a:rPr>
               <a:t>#44CEF6</a:t>
             </a:r>
-            <a:endParaRPr sz="1050" b="0" i="0">
-              <a:solidFill>
-                <a:srgbClr val="161823"/>
-              </a:solidFill>
-              <a:latin typeface="微软雅黑" panose="020B0503020204020204" charset="-122"/>
-              <a:ea typeface="微软雅黑" panose="020B0503020204020204" charset="-122"/>
-            </a:endParaRPr>
           </a:p>
         </p:txBody>
       </p:sp>
@@ -4533,18 +4468,11 @@
                 <a:solidFill>
                   <a:srgbClr val="FFFFFF"/>
                 </a:solidFill>
-                <a:latin typeface="宋体" panose="02010600030101010101" pitchFamily="2" charset="-122"/>
-                <a:ea typeface="宋体" panose="02010600030101010101" pitchFamily="2" charset="-122"/>
+                <a:latin typeface="宋体"/>
+                <a:ea typeface="宋体"/>
               </a:rPr>
               <a:t>宝蓝</a:t>
             </a:r>
-            <a:endParaRPr sz="1800" b="1" i="0">
-              <a:solidFill>
-                <a:srgbClr val="FFFFFF"/>
-              </a:solidFill>
-              <a:latin typeface="宋体" panose="02010600030101010101" pitchFamily="2" charset="-122"/>
-              <a:ea typeface="宋体" panose="02010600030101010101" pitchFamily="2" charset="-122"/>
-            </a:endParaRPr>
           </a:p>
           <a:p>
             <a:pPr algn="l">
@@ -4563,18 +4491,11 @@
                 <a:solidFill>
                   <a:srgbClr val="FFFFFF"/>
                 </a:solidFill>
-                <a:latin typeface="微软雅黑" panose="020B0503020204020204" charset="-122"/>
-                <a:ea typeface="微软雅黑" panose="020B0503020204020204" charset="-122"/>
+                <a:latin typeface="微软雅黑"/>
+                <a:ea typeface="微软雅黑"/>
               </a:rPr>
               <a:t>#4B5CC4</a:t>
             </a:r>
-            <a:endParaRPr sz="1050" b="0" i="0">
-              <a:solidFill>
-                <a:srgbClr val="FFFFFF"/>
-              </a:solidFill>
-              <a:latin typeface="微软雅黑" panose="020B0503020204020204" charset="-122"/>
-              <a:ea typeface="微软雅黑" panose="020B0503020204020204" charset="-122"/>
-            </a:endParaRPr>
           </a:p>
         </p:txBody>
       </p:sp>
@@ -4660,18 +4581,11 @@
                 <a:solidFill>
                   <a:srgbClr val="161823"/>
                 </a:solidFill>
-                <a:latin typeface="宋体" panose="02010600030101010101" pitchFamily="2" charset="-122"/>
-                <a:ea typeface="宋体" panose="02010600030101010101" pitchFamily="2" charset="-122"/>
+                <a:latin typeface="宋体"/>
+                <a:ea typeface="宋体"/>
               </a:rPr>
               <a:t>蓝灰色</a:t>
             </a:r>
-            <a:endParaRPr sz="1800" b="1" i="0">
-              <a:solidFill>
-                <a:srgbClr val="161823"/>
-              </a:solidFill>
-              <a:latin typeface="宋体" panose="02010600030101010101" pitchFamily="2" charset="-122"/>
-              <a:ea typeface="宋体" panose="02010600030101010101" pitchFamily="2" charset="-122"/>
-            </a:endParaRPr>
           </a:p>
           <a:p>
             <a:pPr algn="l">
@@ -4690,18 +4604,11 @@
                 <a:solidFill>
                   <a:srgbClr val="161823"/>
                 </a:solidFill>
-                <a:latin typeface="微软雅黑" panose="020B0503020204020204" charset="-122"/>
-                <a:ea typeface="微软雅黑" panose="020B0503020204020204" charset="-122"/>
+                <a:latin typeface="微软雅黑"/>
+                <a:ea typeface="微软雅黑"/>
               </a:rPr>
               <a:t>#A1AFC9</a:t>
             </a:r>
-            <a:endParaRPr sz="1050" b="0" i="0">
-              <a:solidFill>
-                <a:srgbClr val="161823"/>
-              </a:solidFill>
-              <a:latin typeface="微软雅黑" panose="020B0503020204020204" charset="-122"/>
-              <a:ea typeface="微软雅黑" panose="020B0503020204020204" charset="-122"/>
-            </a:endParaRPr>
           </a:p>
         </p:txBody>
       </p:sp>
@@ -4787,18 +4694,11 @@
                 <a:solidFill>
                   <a:srgbClr val="161823"/>
                 </a:solidFill>
-                <a:latin typeface="宋体" panose="02010600030101010101" pitchFamily="2" charset="-122"/>
-                <a:ea typeface="宋体" panose="02010600030101010101" pitchFamily="2" charset="-122"/>
+                <a:latin typeface="宋体"/>
+                <a:ea typeface="宋体"/>
               </a:rPr>
               <a:t>月白</a:t>
             </a:r>
-            <a:endParaRPr sz="1800" b="1" i="0">
-              <a:solidFill>
-                <a:srgbClr val="161823"/>
-              </a:solidFill>
-              <a:latin typeface="宋体" panose="02010600030101010101" pitchFamily="2" charset="-122"/>
-              <a:ea typeface="宋体" panose="02010600030101010101" pitchFamily="2" charset="-122"/>
-            </a:endParaRPr>
           </a:p>
           <a:p>
             <a:pPr algn="l">
@@ -4817,18 +4717,11 @@
                 <a:solidFill>
                   <a:srgbClr val="161823"/>
                 </a:solidFill>
-                <a:latin typeface="微软雅黑" panose="020B0503020204020204" charset="-122"/>
-                <a:ea typeface="微软雅黑" panose="020B0503020204020204" charset="-122"/>
+                <a:latin typeface="微软雅黑"/>
+                <a:ea typeface="微软雅黑"/>
               </a:rPr>
               <a:t>#D6ECF0</a:t>
             </a:r>
-            <a:endParaRPr sz="1050" b="0" i="0">
-              <a:solidFill>
-                <a:srgbClr val="161823"/>
-              </a:solidFill>
-              <a:latin typeface="微软雅黑" panose="020B0503020204020204" charset="-122"/>
-              <a:ea typeface="微软雅黑" panose="020B0503020204020204" charset="-122"/>
-            </a:endParaRPr>
           </a:p>
         </p:txBody>
       </p:sp>
@@ -4914,18 +4807,11 @@
                 <a:solidFill>
                   <a:srgbClr val="065279"/>
                 </a:solidFill>
-                <a:latin typeface="微软雅黑" panose="020B0503020204020204" charset="-122"/>
-                <a:ea typeface="微软雅黑" panose="020B0503020204020204" charset="-122"/>
+                <a:latin typeface="微软雅黑"/>
+                <a:ea typeface="微软雅黑"/>
               </a:rPr>
               <a:t>靛青 / 靛蓝</a:t>
             </a:r>
-            <a:endParaRPr sz="1250" b="1" i="0">
-              <a:solidFill>
-                <a:srgbClr val="065279"/>
-              </a:solidFill>
-              <a:latin typeface="微软雅黑" panose="020B0503020204020204" charset="-122"/>
-              <a:ea typeface="微软雅黑" panose="020B0503020204020204" charset="-122"/>
-            </a:endParaRPr>
           </a:p>
         </p:txBody>
       </p:sp>
@@ -4967,18 +4853,11 @@
                 <a:solidFill>
                   <a:srgbClr val="50616D"/>
                 </a:solidFill>
-                <a:latin typeface="微软雅黑" panose="020B0503020204020204" charset="-122"/>
-                <a:ea typeface="微软雅黑" panose="020B0503020204020204" charset="-122"/>
+                <a:latin typeface="微软雅黑"/>
+                <a:ea typeface="微软雅黑"/>
               </a:rPr>
               <a:t>标题、导航、图表主序列与强调色块</a:t>
             </a:r>
-            <a:endParaRPr sz="1250" b="0" i="0">
-              <a:solidFill>
-                <a:srgbClr val="50616D"/>
-              </a:solidFill>
-              <a:latin typeface="微软雅黑" panose="020B0503020204020204" charset="-122"/>
-              <a:ea typeface="微软雅黑" panose="020B0503020204020204" charset="-122"/>
-            </a:endParaRPr>
           </a:p>
         </p:txBody>
       </p:sp>
@@ -5064,18 +4943,11 @@
                 <a:solidFill>
                   <a:srgbClr val="065279"/>
                 </a:solidFill>
-                <a:latin typeface="微软雅黑" panose="020B0503020204020204" charset="-122"/>
-                <a:ea typeface="微软雅黑" panose="020B0503020204020204" charset="-122"/>
+                <a:latin typeface="微软雅黑"/>
+                <a:ea typeface="微软雅黑"/>
               </a:rPr>
               <a:t>蓝 / 宝蓝</a:t>
             </a:r>
-            <a:endParaRPr sz="1250" b="1" i="0">
-              <a:solidFill>
-                <a:srgbClr val="065279"/>
-              </a:solidFill>
-              <a:latin typeface="微软雅黑" panose="020B0503020204020204" charset="-122"/>
-              <a:ea typeface="微软雅黑" panose="020B0503020204020204" charset="-122"/>
-            </a:endParaRPr>
           </a:p>
         </p:txBody>
       </p:sp>
@@ -5117,18 +4989,11 @@
                 <a:solidFill>
                   <a:srgbClr val="50616D"/>
                 </a:solidFill>
-                <a:latin typeface="微软雅黑" panose="020B0503020204020204" charset="-122"/>
-                <a:ea typeface="微软雅黑" panose="020B0503020204020204" charset="-122"/>
+                <a:latin typeface="微软雅黑"/>
+                <a:ea typeface="微软雅黑"/>
               </a:rPr>
               <a:t>次级强调、链接、数据辅助系列</a:t>
             </a:r>
-            <a:endParaRPr sz="1250" b="0" i="0">
-              <a:solidFill>
-                <a:srgbClr val="50616D"/>
-              </a:solidFill>
-              <a:latin typeface="微软雅黑" panose="020B0503020204020204" charset="-122"/>
-              <a:ea typeface="微软雅黑" panose="020B0503020204020204" charset="-122"/>
-            </a:endParaRPr>
           </a:p>
         </p:txBody>
       </p:sp>
@@ -5214,18 +5079,11 @@
                 <a:solidFill>
                   <a:srgbClr val="065279"/>
                 </a:solidFill>
-                <a:latin typeface="微软雅黑" panose="020B0503020204020204" charset="-122"/>
-                <a:ea typeface="微软雅黑" panose="020B0503020204020204" charset="-122"/>
+                <a:latin typeface="微软雅黑"/>
+                <a:ea typeface="微软雅黑"/>
               </a:rPr>
               <a:t>月白 / 蓝灰</a:t>
             </a:r>
-            <a:endParaRPr sz="1250" b="1" i="0">
-              <a:solidFill>
-                <a:srgbClr val="065279"/>
-              </a:solidFill>
-              <a:latin typeface="微软雅黑" panose="020B0503020204020204" charset="-122"/>
-              <a:ea typeface="微软雅黑" panose="020B0503020204020204" charset="-122"/>
-            </a:endParaRPr>
           </a:p>
         </p:txBody>
       </p:sp>
@@ -5267,18 +5125,11 @@
                 <a:solidFill>
                   <a:srgbClr val="50616D"/>
                 </a:solidFill>
-                <a:latin typeface="微软雅黑" panose="020B0503020204020204" charset="-122"/>
-                <a:ea typeface="微软雅黑" panose="020B0503020204020204" charset="-122"/>
+                <a:latin typeface="微软雅黑"/>
+                <a:ea typeface="微软雅黑"/>
               </a:rPr>
               <a:t>大面积浅底、留白过渡、安静面板</a:t>
             </a:r>
-            <a:endParaRPr sz="1250" b="0" i="0">
-              <a:solidFill>
-                <a:srgbClr val="50616D"/>
-              </a:solidFill>
-              <a:latin typeface="微软雅黑" panose="020B0503020204020204" charset="-122"/>
-              <a:ea typeface="微软雅黑" panose="020B0503020204020204" charset="-122"/>
-            </a:endParaRPr>
           </a:p>
         </p:txBody>
       </p:sp>
@@ -5364,18 +5215,11 @@
                 <a:solidFill>
                   <a:srgbClr val="065279"/>
                 </a:solidFill>
-                <a:latin typeface="微软雅黑" panose="020B0503020204020204" charset="-122"/>
-                <a:ea typeface="微软雅黑" panose="020B0503020204020204" charset="-122"/>
+                <a:latin typeface="微软雅黑"/>
+                <a:ea typeface="微软雅黑"/>
               </a:rPr>
               <a:t>金色 · 胭脂</a:t>
             </a:r>
-            <a:endParaRPr sz="1250" b="1" i="0">
-              <a:solidFill>
-                <a:srgbClr val="065279"/>
-              </a:solidFill>
-              <a:latin typeface="微软雅黑" panose="020B0503020204020204" charset="-122"/>
-              <a:ea typeface="微软雅黑" panose="020B0503020204020204" charset="-122"/>
-            </a:endParaRPr>
           </a:p>
         </p:txBody>
       </p:sp>
@@ -5417,18 +5261,11 @@
                 <a:solidFill>
                   <a:srgbClr val="50616D"/>
                 </a:solidFill>
-                <a:latin typeface="微软雅黑" panose="020B0503020204020204" charset="-122"/>
-                <a:ea typeface="微软雅黑" panose="020B0503020204020204" charset="-122"/>
+                <a:latin typeface="微软雅黑"/>
+                <a:ea typeface="微软雅黑"/>
               </a:rPr>
               <a:t>细分割线点睛、印章红仅作节奏锚点</a:t>
             </a:r>
-            <a:endParaRPr sz="1250" b="0" i="0">
-              <a:solidFill>
-                <a:srgbClr val="50616D"/>
-              </a:solidFill>
-              <a:latin typeface="微软雅黑" panose="020B0503020204020204" charset="-122"/>
-              <a:ea typeface="微软雅黑" panose="020B0503020204020204" charset="-122"/>
-            </a:endParaRPr>
           </a:p>
         </p:txBody>
       </p:sp>
@@ -5441,7 +5278,7 @@
 </file>
 
 <file path=ppt/slides/slide3.xml><?xml version="1.0" encoding="utf-8"?>
-<p:sld xmlns:a="http://schemas.openxmlformats.org/drawingml/2006/main" xmlns:r="http://schemas.openxmlformats.org/officeDocument/2006/relationships" xmlns:p="http://schemas.openxmlformats.org/presentationml/2006/main">
+<p:sld xmlns:a="http://schemas.openxmlformats.org/drawingml/2006/main" xmlns:p="http://schemas.openxmlformats.org/presentationml/2006/main" xmlns:r="http://schemas.openxmlformats.org/officeDocument/2006/relationships">
   <p:cSld>
     <p:bg>
       <p:bgPr>
@@ -5460,14 +5297,14 @@
       <p:grpSpPr/>
       <p:pic>
         <p:nvPicPr>
-          <p:cNvPr id="2" name="Picture 1" descr="paper_texture.png"/>
+          <p:cNvPr id="2" name="Picture 1" descr="rice_paper_bg.png"/>
           <p:cNvPicPr>
             <a:picLocks noChangeAspect="1"/>
           </p:cNvPicPr>
           <p:nvPr/>
         </p:nvPicPr>
         <p:blipFill>
-          <a:blip r:embed="rId1"/>
+          <a:blip r:embed="rId2"/>
           <a:stretch>
             <a:fillRect/>
           </a:stretch>
@@ -5578,7 +5415,7 @@
         </p:nvSpPr>
         <p:spPr>
           <a:xfrm>
-            <a:off x="475615" y="621919"/>
+            <a:off x="640080" y="603504"/>
             <a:ext cx="548640" cy="457200"/>
           </a:xfrm>
           <a:prstGeom prst="rect">
@@ -5608,18 +5445,11 @@
                 <a:solidFill>
                   <a:srgbClr val="FFFBF0"/>
                 </a:solidFill>
-                <a:latin typeface="宋体" panose="02010600030101010101" pitchFamily="2" charset="-122"/>
-                <a:ea typeface="宋体" panose="02010600030101010101" pitchFamily="2" charset="-122"/>
+                <a:latin typeface="宋体"/>
+                <a:ea typeface="宋体"/>
               </a:rPr>
               <a:t>录</a:t>
             </a:r>
-            <a:endParaRPr sz="1500" b="1" i="0">
-              <a:solidFill>
-                <a:srgbClr val="FFFBF0"/>
-              </a:solidFill>
-              <a:latin typeface="宋体" panose="02010600030101010101" pitchFamily="2" charset="-122"/>
-              <a:ea typeface="宋体" panose="02010600030101010101" pitchFamily="2" charset="-122"/>
-            </a:endParaRPr>
           </a:p>
         </p:txBody>
       </p:sp>
@@ -5661,18 +5491,11 @@
                 <a:solidFill>
                   <a:srgbClr val="161823"/>
                 </a:solidFill>
-                <a:latin typeface="宋体" panose="02010600030101010101" pitchFamily="2" charset="-122"/>
-                <a:ea typeface="宋体" panose="02010600030101010101" pitchFamily="2" charset="-122"/>
+                <a:latin typeface="宋体"/>
+                <a:ea typeface="宋体"/>
               </a:rPr>
               <a:t>目录 · 五个章节</a:t>
             </a:r>
-            <a:endParaRPr sz="2700" b="1" i="0">
-              <a:solidFill>
-                <a:srgbClr val="161823"/>
-              </a:solidFill>
-              <a:latin typeface="宋体" panose="02010600030101010101" pitchFamily="2" charset="-122"/>
-              <a:ea typeface="宋体" panose="02010600030101010101" pitchFamily="2" charset="-122"/>
-            </a:endParaRPr>
           </a:p>
         </p:txBody>
       </p:sp>
@@ -5714,18 +5537,11 @@
                 <a:solidFill>
                   <a:srgbClr val="177CB0"/>
                 </a:solidFill>
-                <a:latin typeface="微软雅黑" panose="020B0503020204020204" charset="-122"/>
-                <a:ea typeface="微软雅黑" panose="020B0503020204020204" charset="-122"/>
+                <a:latin typeface="微软雅黑"/>
+                <a:ea typeface="微软雅黑"/>
               </a:rPr>
               <a:t>AGENDA</a:t>
             </a:r>
-            <a:endParaRPr sz="1200" b="0" i="0">
-              <a:solidFill>
-                <a:srgbClr val="177CB0"/>
-              </a:solidFill>
-              <a:latin typeface="微软雅黑" panose="020B0503020204020204" charset="-122"/>
-              <a:ea typeface="微软雅黑" panose="020B0503020204020204" charset="-122"/>
-            </a:endParaRPr>
           </a:p>
         </p:txBody>
       </p:sp>
@@ -5893,18 +5709,11 @@
                 <a:solidFill>
                   <a:srgbClr val="177CB0"/>
                 </a:solidFill>
-                <a:latin typeface="宋体" panose="02010600030101010101" pitchFamily="2" charset="-122"/>
-                <a:ea typeface="宋体" panose="02010600030101010101" pitchFamily="2" charset="-122"/>
+                <a:latin typeface="宋体"/>
+                <a:ea typeface="宋体"/>
               </a:rPr>
               <a:t>01</a:t>
             </a:r>
-            <a:endParaRPr sz="3000" b="1" i="0">
-              <a:solidFill>
-                <a:srgbClr val="177CB0"/>
-              </a:solidFill>
-              <a:latin typeface="宋体" panose="02010600030101010101" pitchFamily="2" charset="-122"/>
-              <a:ea typeface="宋体" panose="02010600030101010101" pitchFamily="2" charset="-122"/>
-            </a:endParaRPr>
           </a:p>
         </p:txBody>
       </p:sp>
@@ -5946,18 +5755,11 @@
                 <a:solidFill>
                   <a:srgbClr val="161823"/>
                 </a:solidFill>
-                <a:latin typeface="微软雅黑" panose="020B0503020204020204" charset="-122"/>
-                <a:ea typeface="微软雅黑" panose="020B0503020204020204" charset="-122"/>
+                <a:latin typeface="微软雅黑"/>
+                <a:ea typeface="微软雅黑"/>
               </a:rPr>
               <a:t>工作流总览</a:t>
             </a:r>
-            <a:endParaRPr sz="1800" b="1" i="0">
-              <a:solidFill>
-                <a:srgbClr val="161823"/>
-              </a:solidFill>
-              <a:latin typeface="微软雅黑" panose="020B0503020204020204" charset="-122"/>
-              <a:ea typeface="微软雅黑" panose="020B0503020204020204" charset="-122"/>
-            </a:endParaRPr>
           </a:p>
           <a:p>
             <a:pPr algn="l">
@@ -5976,18 +5778,11 @@
                 <a:solidFill>
                   <a:srgbClr val="50616D"/>
                 </a:solidFill>
-                <a:latin typeface="微软雅黑" panose="020B0503020204020204" charset="-122"/>
-                <a:ea typeface="微软雅黑" panose="020B0503020204020204" charset="-122"/>
+                <a:latin typeface="微软雅黑"/>
+                <a:ea typeface="微软雅黑"/>
               </a:rPr>
               <a:t>Agent + Skill + MCP 三件套如何协作</a:t>
             </a:r>
-            <a:endParaRPr sz="1200" b="0" i="0">
-              <a:solidFill>
-                <a:srgbClr val="50616D"/>
-              </a:solidFill>
-              <a:latin typeface="微软雅黑" panose="020B0503020204020204" charset="-122"/>
-              <a:ea typeface="微软雅黑" panose="020B0503020204020204" charset="-122"/>
-            </a:endParaRPr>
           </a:p>
         </p:txBody>
       </p:sp>
@@ -6119,18 +5914,11 @@
                 <a:solidFill>
                   <a:srgbClr val="177CB0"/>
                 </a:solidFill>
-                <a:latin typeface="宋体" panose="02010600030101010101" pitchFamily="2" charset="-122"/>
-                <a:ea typeface="宋体" panose="02010600030101010101" pitchFamily="2" charset="-122"/>
+                <a:latin typeface="宋体"/>
+                <a:ea typeface="宋体"/>
               </a:rPr>
               <a:t>02</a:t>
             </a:r>
-            <a:endParaRPr sz="3000" b="1" i="0">
-              <a:solidFill>
-                <a:srgbClr val="177CB0"/>
-              </a:solidFill>
-              <a:latin typeface="宋体" panose="02010600030101010101" pitchFamily="2" charset="-122"/>
-              <a:ea typeface="宋体" panose="02010600030101010101" pitchFamily="2" charset="-122"/>
-            </a:endParaRPr>
           </a:p>
         </p:txBody>
       </p:sp>
@@ -6172,18 +5960,11 @@
                 <a:solidFill>
                   <a:srgbClr val="161823"/>
                 </a:solidFill>
-                <a:latin typeface="微软雅黑" panose="020B0503020204020204" charset="-122"/>
-                <a:ea typeface="微软雅黑" panose="020B0503020204020204" charset="-122"/>
+                <a:latin typeface="微软雅黑"/>
+                <a:ea typeface="微软雅黑"/>
               </a:rPr>
               <a:t>选型建议</a:t>
             </a:r>
-            <a:endParaRPr sz="1800" b="1" i="0">
-              <a:solidFill>
-                <a:srgbClr val="161823"/>
-              </a:solidFill>
-              <a:latin typeface="微软雅黑" panose="020B0503020204020204" charset="-122"/>
-              <a:ea typeface="微软雅黑" panose="020B0503020204020204" charset="-122"/>
-            </a:endParaRPr>
           </a:p>
           <a:p>
             <a:pPr algn="l">
@@ -6202,18 +5983,11 @@
                 <a:solidFill>
                   <a:srgbClr val="50616D"/>
                 </a:solidFill>
-                <a:latin typeface="微软雅黑" panose="020B0503020204020204" charset="-122"/>
-                <a:ea typeface="微软雅黑" panose="020B0503020204020204" charset="-122"/>
+                <a:latin typeface="微软雅黑"/>
+                <a:ea typeface="微软雅黑"/>
               </a:rPr>
               <a:t>Agent 与大模型，2026 年的推荐组合</a:t>
             </a:r>
-            <a:endParaRPr sz="1200" b="0" i="0">
-              <a:solidFill>
-                <a:srgbClr val="50616D"/>
-              </a:solidFill>
-              <a:latin typeface="微软雅黑" panose="020B0503020204020204" charset="-122"/>
-              <a:ea typeface="微软雅黑" panose="020B0503020204020204" charset="-122"/>
-            </a:endParaRPr>
           </a:p>
         </p:txBody>
       </p:sp>
@@ -6345,18 +6119,11 @@
                 <a:solidFill>
                   <a:srgbClr val="177CB0"/>
                 </a:solidFill>
-                <a:latin typeface="宋体" panose="02010600030101010101" pitchFamily="2" charset="-122"/>
-                <a:ea typeface="宋体" panose="02010600030101010101" pitchFamily="2" charset="-122"/>
+                <a:latin typeface="宋体"/>
+                <a:ea typeface="宋体"/>
               </a:rPr>
               <a:t>03</a:t>
             </a:r>
-            <a:endParaRPr sz="3000" b="1" i="0">
-              <a:solidFill>
-                <a:srgbClr val="177CB0"/>
-              </a:solidFill>
-              <a:latin typeface="宋体" panose="02010600030101010101" pitchFamily="2" charset="-122"/>
-              <a:ea typeface="宋体" panose="02010600030101010101" pitchFamily="2" charset="-122"/>
-            </a:endParaRPr>
           </a:p>
         </p:txBody>
       </p:sp>
@@ -6398,18 +6165,11 @@
                 <a:solidFill>
                   <a:srgbClr val="161823"/>
                 </a:solidFill>
-                <a:latin typeface="微软雅黑" panose="020B0503020204020204" charset="-122"/>
-                <a:ea typeface="微软雅黑" panose="020B0503020204020204" charset="-122"/>
+                <a:latin typeface="微软雅黑"/>
+                <a:ea typeface="微软雅黑"/>
               </a:rPr>
               <a:t>安装与调用</a:t>
             </a:r>
-            <a:endParaRPr sz="1800" b="1" i="0">
-              <a:solidFill>
-                <a:srgbClr val="161823"/>
-              </a:solidFill>
-              <a:latin typeface="微软雅黑" panose="020B0503020204020204" charset="-122"/>
-              <a:ea typeface="微软雅黑" panose="020B0503020204020204" charset="-122"/>
-            </a:endParaRPr>
           </a:p>
           <a:p>
             <a:pPr algn="l">
@@ -6428,18 +6188,11 @@
                 <a:solidFill>
                   <a:srgbClr val="50616D"/>
                 </a:solidFill>
-                <a:latin typeface="微软雅黑" panose="020B0503020204020204" charset="-122"/>
-                <a:ea typeface="微软雅黑" panose="020B0503020204020204" charset="-122"/>
+                <a:latin typeface="微软雅黑"/>
+                <a:ea typeface="微软雅黑"/>
               </a:rPr>
               <a:t>如何为环境装上 skill 并精确触发</a:t>
             </a:r>
-            <a:endParaRPr sz="1200" b="0" i="0">
-              <a:solidFill>
-                <a:srgbClr val="50616D"/>
-              </a:solidFill>
-              <a:latin typeface="微软雅黑" panose="020B0503020204020204" charset="-122"/>
-              <a:ea typeface="微软雅黑" panose="020B0503020204020204" charset="-122"/>
-            </a:endParaRPr>
           </a:p>
         </p:txBody>
       </p:sp>
@@ -6571,18 +6324,11 @@
                 <a:solidFill>
                   <a:srgbClr val="177CB0"/>
                 </a:solidFill>
-                <a:latin typeface="宋体" panose="02010600030101010101" pitchFamily="2" charset="-122"/>
-                <a:ea typeface="宋体" panose="02010600030101010101" pitchFamily="2" charset="-122"/>
+                <a:latin typeface="宋体"/>
+                <a:ea typeface="宋体"/>
               </a:rPr>
               <a:t>04</a:t>
             </a:r>
-            <a:endParaRPr sz="3000" b="1" i="0">
-              <a:solidFill>
-                <a:srgbClr val="177CB0"/>
-              </a:solidFill>
-              <a:latin typeface="宋体" panose="02010600030101010101" pitchFamily="2" charset="-122"/>
-              <a:ea typeface="宋体" panose="02010600030101010101" pitchFamily="2" charset="-122"/>
-            </a:endParaRPr>
           </a:p>
         </p:txBody>
       </p:sp>
@@ -6624,18 +6370,11 @@
                 <a:solidFill>
                   <a:srgbClr val="161823"/>
                 </a:solidFill>
-                <a:latin typeface="微软雅黑" panose="020B0503020204020204" charset="-122"/>
-                <a:ea typeface="微软雅黑" panose="020B0503020204020204" charset="-122"/>
+                <a:latin typeface="微软雅黑"/>
+                <a:ea typeface="微软雅黑"/>
               </a:rPr>
               <a:t>产物与格式</a:t>
             </a:r>
-            <a:endParaRPr sz="1800" b="1" i="0">
-              <a:solidFill>
-                <a:srgbClr val="161823"/>
-              </a:solidFill>
-              <a:latin typeface="微软雅黑" panose="020B0503020204020204" charset="-122"/>
-              <a:ea typeface="微软雅黑" panose="020B0503020204020204" charset="-122"/>
-            </a:endParaRPr>
           </a:p>
           <a:p>
             <a:pPr algn="l">
@@ -6654,18 +6393,11 @@
                 <a:solidFill>
                   <a:srgbClr val="50616D"/>
                 </a:solidFill>
-                <a:latin typeface="微软雅黑" panose="020B0503020204020204" charset="-122"/>
-                <a:ea typeface="微软雅黑" panose="020B0503020204020204" charset="-122"/>
+                <a:latin typeface="微软雅黑"/>
+                <a:ea typeface="微软雅黑"/>
               </a:rPr>
               <a:t>为什么要可编辑的 SVG / PPT / PDF</a:t>
             </a:r>
-            <a:endParaRPr sz="1200" b="0" i="0">
-              <a:solidFill>
-                <a:srgbClr val="50616D"/>
-              </a:solidFill>
-              <a:latin typeface="微软雅黑" panose="020B0503020204020204" charset="-122"/>
-              <a:ea typeface="微软雅黑" panose="020B0503020204020204" charset="-122"/>
-            </a:endParaRPr>
           </a:p>
         </p:txBody>
       </p:sp>
@@ -6797,18 +6529,11 @@
                 <a:solidFill>
                   <a:srgbClr val="177CB0"/>
                 </a:solidFill>
-                <a:latin typeface="宋体" panose="02010600030101010101" pitchFamily="2" charset="-122"/>
-                <a:ea typeface="宋体" panose="02010600030101010101" pitchFamily="2" charset="-122"/>
+                <a:latin typeface="宋体"/>
+                <a:ea typeface="宋体"/>
               </a:rPr>
               <a:t>05</a:t>
             </a:r>
-            <a:endParaRPr sz="3000" b="1" i="0">
-              <a:solidFill>
-                <a:srgbClr val="177CB0"/>
-              </a:solidFill>
-              <a:latin typeface="宋体" panose="02010600030101010101" pitchFamily="2" charset="-122"/>
-              <a:ea typeface="宋体" panose="02010600030101010101" pitchFamily="2" charset="-122"/>
-            </a:endParaRPr>
           </a:p>
         </p:txBody>
       </p:sp>
@@ -6850,18 +6575,11 @@
                 <a:solidFill>
                   <a:srgbClr val="161823"/>
                 </a:solidFill>
-                <a:latin typeface="微软雅黑" panose="020B0503020204020204" charset="-122"/>
-                <a:ea typeface="微软雅黑" panose="020B0503020204020204" charset="-122"/>
+                <a:latin typeface="微软雅黑"/>
+                <a:ea typeface="微软雅黑"/>
               </a:rPr>
               <a:t>微调的边界</a:t>
             </a:r>
-            <a:endParaRPr sz="1800" b="1" i="0">
-              <a:solidFill>
-                <a:srgbClr val="161823"/>
-              </a:solidFill>
-              <a:latin typeface="微软雅黑" panose="020B0503020204020204" charset="-122"/>
-              <a:ea typeface="微软雅黑" panose="020B0503020204020204" charset="-122"/>
-            </a:endParaRPr>
           </a:p>
           <a:p>
             <a:pPr algn="l">
@@ -6880,18 +6598,11 @@
                 <a:solidFill>
                   <a:srgbClr val="50616D"/>
                 </a:solidFill>
-                <a:latin typeface="微软雅黑" panose="020B0503020204020204" charset="-122"/>
-                <a:ea typeface="微软雅黑" panose="020B0503020204020204" charset="-122"/>
+                <a:latin typeface="微软雅黑"/>
+                <a:ea typeface="微软雅黑"/>
               </a:rPr>
               <a:t>哪些该交给 AI，哪些该自己动手</a:t>
             </a:r>
-            <a:endParaRPr sz="1200" b="0" i="0">
-              <a:solidFill>
-                <a:srgbClr val="50616D"/>
-              </a:solidFill>
-              <a:latin typeface="微软雅黑" panose="020B0503020204020204" charset="-122"/>
-              <a:ea typeface="微软雅黑" panose="020B0503020204020204" charset="-122"/>
-            </a:endParaRPr>
           </a:p>
         </p:txBody>
       </p:sp>
@@ -6904,7 +6615,7 @@
 </file>
 
 <file path=ppt/slides/slide4.xml><?xml version="1.0" encoding="utf-8"?>
-<p:sld xmlns:a="http://schemas.openxmlformats.org/drawingml/2006/main" xmlns:r="http://schemas.openxmlformats.org/officeDocument/2006/relationships" xmlns:p="http://schemas.openxmlformats.org/presentationml/2006/main">
+<p:sld xmlns:a="http://schemas.openxmlformats.org/drawingml/2006/main" xmlns:p="http://schemas.openxmlformats.org/presentationml/2006/main" xmlns:r="http://schemas.openxmlformats.org/officeDocument/2006/relationships">
   <p:cSld>
     <p:bg>
       <p:bgPr>
@@ -6923,14 +6634,14 @@
       <p:grpSpPr/>
       <p:pic>
         <p:nvPicPr>
-          <p:cNvPr id="2" name="Picture 1" descr="paper_texture.png"/>
+          <p:cNvPr id="2" name="Picture 1" descr="rice_paper_bg.png"/>
           <p:cNvPicPr>
             <a:picLocks noChangeAspect="1"/>
           </p:cNvPicPr>
           <p:nvPr/>
         </p:nvPicPr>
         <p:blipFill>
-          <a:blip r:embed="rId1"/>
+          <a:blip r:embed="rId2"/>
           <a:stretch>
             <a:fillRect/>
           </a:stretch>
@@ -7041,7 +6752,7 @@
         </p:nvSpPr>
         <p:spPr>
           <a:xfrm>
-            <a:off x="475615" y="621919"/>
+            <a:off x="640080" y="603504"/>
             <a:ext cx="548640" cy="457200"/>
           </a:xfrm>
           <a:prstGeom prst="rect">
@@ -7071,18 +6782,11 @@
                 <a:solidFill>
                   <a:srgbClr val="FFFBF0"/>
                 </a:solidFill>
-                <a:latin typeface="宋体" panose="02010600030101010101" pitchFamily="2" charset="-122"/>
-                <a:ea typeface="宋体" panose="02010600030101010101" pitchFamily="2" charset="-122"/>
+                <a:latin typeface="宋体"/>
+                <a:ea typeface="宋体"/>
               </a:rPr>
               <a:t>流</a:t>
             </a:r>
-            <a:endParaRPr sz="1500" b="1" i="0">
-              <a:solidFill>
-                <a:srgbClr val="FFFBF0"/>
-              </a:solidFill>
-              <a:latin typeface="宋体" panose="02010600030101010101" pitchFamily="2" charset="-122"/>
-              <a:ea typeface="宋体" panose="02010600030101010101" pitchFamily="2" charset="-122"/>
-            </a:endParaRPr>
           </a:p>
         </p:txBody>
       </p:sp>
@@ -7124,18 +6828,11 @@
                 <a:solidFill>
                   <a:srgbClr val="161823"/>
                 </a:solidFill>
-                <a:latin typeface="宋体" panose="02010600030101010101" pitchFamily="2" charset="-122"/>
-                <a:ea typeface="宋体" panose="02010600030101010101" pitchFamily="2" charset="-122"/>
+                <a:latin typeface="宋体"/>
+                <a:ea typeface="宋体"/>
               </a:rPr>
               <a:t>工作流总览 · Agent + Skill + MCP</a:t>
             </a:r>
-            <a:endParaRPr sz="2700" b="1" i="0">
-              <a:solidFill>
-                <a:srgbClr val="161823"/>
-              </a:solidFill>
-              <a:latin typeface="宋体" panose="02010600030101010101" pitchFamily="2" charset="-122"/>
-              <a:ea typeface="宋体" panose="02010600030101010101" pitchFamily="2" charset="-122"/>
-            </a:endParaRPr>
           </a:p>
         </p:txBody>
       </p:sp>
@@ -7177,18 +6874,11 @@
                 <a:solidFill>
                   <a:srgbClr val="177CB0"/>
                 </a:solidFill>
-                <a:latin typeface="微软雅黑" panose="020B0503020204020204" charset="-122"/>
-                <a:ea typeface="微软雅黑" panose="020B0503020204020204" charset="-122"/>
+                <a:latin typeface="微软雅黑"/>
+                <a:ea typeface="微软雅黑"/>
               </a:rPr>
               <a:t>HOW THE PIECES FIT</a:t>
             </a:r>
-            <a:endParaRPr sz="1200" b="0" i="0">
-              <a:solidFill>
-                <a:srgbClr val="177CB0"/>
-              </a:solidFill>
-              <a:latin typeface="微软雅黑" panose="020B0503020204020204" charset="-122"/>
-              <a:ea typeface="微软雅黑" panose="020B0503020204020204" charset="-122"/>
-            </a:endParaRPr>
           </a:p>
         </p:txBody>
       </p:sp>
@@ -7266,18 +6956,11 @@
                 <a:solidFill>
                   <a:srgbClr val="50616D"/>
                 </a:solidFill>
-                <a:latin typeface="微软雅黑" panose="020B0503020204020204" charset="-122"/>
-                <a:ea typeface="微软雅黑" panose="020B0503020204020204" charset="-122"/>
+                <a:latin typeface="微软雅黑"/>
+                <a:ea typeface="微软雅黑"/>
               </a:rPr>
               <a:t>当前主流程是「智能体 + 技能 + 工具」三件套协作。以做一张科研流程图为例：</a:t>
             </a:r>
-            <a:endParaRPr sz="1350" b="0" i="0">
-              <a:solidFill>
-                <a:srgbClr val="50616D"/>
-              </a:solidFill>
-              <a:latin typeface="微软雅黑" panose="020B0503020204020204" charset="-122"/>
-              <a:ea typeface="微软雅黑" panose="020B0503020204020204" charset="-122"/>
-            </a:endParaRPr>
           </a:p>
         </p:txBody>
       </p:sp>
@@ -7409,18 +7092,11 @@
                 <a:solidFill>
                   <a:srgbClr val="FFFFFF"/>
                 </a:solidFill>
-                <a:latin typeface="微软雅黑" panose="020B0503020204020204" charset="-122"/>
-                <a:ea typeface="微软雅黑" panose="020B0503020204020204" charset="-122"/>
+                <a:latin typeface="微软雅黑"/>
+                <a:ea typeface="微软雅黑"/>
               </a:rPr>
               <a:t>Agent</a:t>
             </a:r>
-            <a:endParaRPr sz="2000" b="1" i="0">
-              <a:solidFill>
-                <a:srgbClr val="FFFFFF"/>
-              </a:solidFill>
-              <a:latin typeface="微软雅黑" panose="020B0503020204020204" charset="-122"/>
-              <a:ea typeface="微软雅黑" panose="020B0503020204020204" charset="-122"/>
-            </a:endParaRPr>
           </a:p>
           <a:p>
             <a:pPr algn="l">
@@ -7439,18 +7115,11 @@
                 <a:solidFill>
                   <a:srgbClr val="D6ECF0"/>
                 </a:solidFill>
-                <a:latin typeface="微软雅黑" panose="020B0503020204020204" charset="-122"/>
-                <a:ea typeface="微软雅黑" panose="020B0503020204020204" charset="-122"/>
+                <a:latin typeface="微软雅黑"/>
+                <a:ea typeface="微软雅黑"/>
               </a:rPr>
               <a:t>智能体</a:t>
             </a:r>
-            <a:endParaRPr sz="1200" b="0" i="0">
-              <a:solidFill>
-                <a:srgbClr val="D6ECF0"/>
-              </a:solidFill>
-              <a:latin typeface="微软雅黑" panose="020B0503020204020204" charset="-122"/>
-              <a:ea typeface="微软雅黑" panose="020B0503020204020204" charset="-122"/>
-            </a:endParaRPr>
           </a:p>
         </p:txBody>
       </p:sp>
@@ -7492,18 +7161,11 @@
                 <a:solidFill>
                   <a:srgbClr val="50616D"/>
                 </a:solidFill>
-                <a:latin typeface="微软雅黑" panose="020B0503020204020204" charset="-122"/>
-                <a:ea typeface="微软雅黑" panose="020B0503020204020204" charset="-122"/>
+                <a:latin typeface="微软雅黑"/>
+                <a:ea typeface="微软雅黑"/>
               </a:rPr>
               <a:t>Codex / Claude Code / Cursor —</a:t>
             </a:r>
-            <a:endParaRPr sz="1250" b="0" i="0">
-              <a:solidFill>
-                <a:srgbClr val="50616D"/>
-              </a:solidFill>
-              <a:latin typeface="微软雅黑" panose="020B0503020204020204" charset="-122"/>
-              <a:ea typeface="微软雅黑" panose="020B0503020204020204" charset="-122"/>
-            </a:endParaRPr>
           </a:p>
           <a:p>
             <a:pPr algn="l">
@@ -7522,18 +7184,11 @@
                 <a:solidFill>
                   <a:srgbClr val="50616D"/>
                 </a:solidFill>
-                <a:latin typeface="微软雅黑" panose="020B0503020204020204" charset="-122"/>
-                <a:ea typeface="微软雅黑" panose="020B0503020204020204" charset="-122"/>
+                <a:latin typeface="微软雅黑"/>
+                <a:ea typeface="微软雅黑"/>
               </a:rPr>
               <a:t>读懂意图、调度技能与工具、产出文件。</a:t>
             </a:r>
-            <a:endParaRPr sz="1250" b="0" i="0">
-              <a:solidFill>
-                <a:srgbClr val="50616D"/>
-              </a:solidFill>
-              <a:latin typeface="微软雅黑" panose="020B0503020204020204" charset="-122"/>
-              <a:ea typeface="微软雅黑" panose="020B0503020204020204" charset="-122"/>
-            </a:endParaRPr>
           </a:p>
         </p:txBody>
       </p:sp>
@@ -7575,18 +7230,11 @@
                 <a:solidFill>
                   <a:srgbClr val="EACD76"/>
                 </a:solidFill>
-                <a:latin typeface="微软雅黑" panose="020B0503020204020204" charset="-122"/>
-                <a:ea typeface="微软雅黑" panose="020B0503020204020204" charset="-122"/>
+                <a:latin typeface="微软雅黑"/>
+                <a:ea typeface="微软雅黑"/>
               </a:rPr>
               <a:t>＋</a:t>
             </a:r>
-            <a:endParaRPr sz="2200" b="1" i="0">
-              <a:solidFill>
-                <a:srgbClr val="EACD76"/>
-              </a:solidFill>
-              <a:latin typeface="微软雅黑" panose="020B0503020204020204" charset="-122"/>
-              <a:ea typeface="微软雅黑" panose="020B0503020204020204" charset="-122"/>
-            </a:endParaRPr>
           </a:p>
         </p:txBody>
       </p:sp>
@@ -7718,18 +7366,11 @@
                 <a:solidFill>
                   <a:srgbClr val="FFFFFF"/>
                 </a:solidFill>
-                <a:latin typeface="微软雅黑" panose="020B0503020204020204" charset="-122"/>
-                <a:ea typeface="微软雅黑" panose="020B0503020204020204" charset="-122"/>
+                <a:latin typeface="微软雅黑"/>
+                <a:ea typeface="微软雅黑"/>
               </a:rPr>
               <a:t>Skill</a:t>
             </a:r>
-            <a:endParaRPr sz="2000" b="1" i="0">
-              <a:solidFill>
-                <a:srgbClr val="FFFFFF"/>
-              </a:solidFill>
-              <a:latin typeface="微软雅黑" panose="020B0503020204020204" charset="-122"/>
-              <a:ea typeface="微软雅黑" panose="020B0503020204020204" charset="-122"/>
-            </a:endParaRPr>
           </a:p>
           <a:p>
             <a:pPr algn="l">
@@ -7748,18 +7389,11 @@
                 <a:solidFill>
                   <a:srgbClr val="D6ECF0"/>
                 </a:solidFill>
-                <a:latin typeface="微软雅黑" panose="020B0503020204020204" charset="-122"/>
-                <a:ea typeface="微软雅黑" panose="020B0503020204020204" charset="-122"/>
+                <a:latin typeface="微软雅黑"/>
+                <a:ea typeface="微软雅黑"/>
               </a:rPr>
               <a:t>技能</a:t>
             </a:r>
-            <a:endParaRPr sz="1200" b="0" i="0">
-              <a:solidFill>
-                <a:srgbClr val="D6ECF0"/>
-              </a:solidFill>
-              <a:latin typeface="微软雅黑" panose="020B0503020204020204" charset="-122"/>
-              <a:ea typeface="微软雅黑" panose="020B0503020204020204" charset="-122"/>
-            </a:endParaRPr>
           </a:p>
         </p:txBody>
       </p:sp>
@@ -7801,18 +7435,11 @@
                 <a:solidFill>
                   <a:srgbClr val="50616D"/>
                 </a:solidFill>
-                <a:latin typeface="微软雅黑" panose="020B0503020204020204" charset="-122"/>
-                <a:ea typeface="微软雅黑" panose="020B0503020204020204" charset="-122"/>
+                <a:latin typeface="微软雅黑"/>
+                <a:ea typeface="微软雅黑"/>
               </a:rPr>
               <a:t>my-design-style 这类设计技能 —</a:t>
             </a:r>
-            <a:endParaRPr sz="1250" b="0" i="0">
-              <a:solidFill>
-                <a:srgbClr val="50616D"/>
-              </a:solidFill>
-              <a:latin typeface="微软雅黑" panose="020B0503020204020204" charset="-122"/>
-              <a:ea typeface="微软雅黑" panose="020B0503020204020204" charset="-122"/>
-            </a:endParaRPr>
           </a:p>
           <a:p>
             <a:pPr algn="l">
@@ -7831,18 +7458,11 @@
                 <a:solidFill>
                   <a:srgbClr val="50616D"/>
                 </a:solidFill>
-                <a:latin typeface="微软雅黑" panose="020B0503020204020204" charset="-122"/>
-                <a:ea typeface="微软雅黑" panose="020B0503020204020204" charset="-122"/>
+                <a:latin typeface="微软雅黑"/>
+                <a:ea typeface="微软雅黑"/>
               </a:rPr>
               <a:t>注入风格契约、色卡、版式与质量门。</a:t>
             </a:r>
-            <a:endParaRPr sz="1250" b="0" i="0">
-              <a:solidFill>
-                <a:srgbClr val="50616D"/>
-              </a:solidFill>
-              <a:latin typeface="微软雅黑" panose="020B0503020204020204" charset="-122"/>
-              <a:ea typeface="微软雅黑" panose="020B0503020204020204" charset="-122"/>
-            </a:endParaRPr>
           </a:p>
         </p:txBody>
       </p:sp>
@@ -7884,18 +7504,11 @@
                 <a:solidFill>
                   <a:srgbClr val="EACD76"/>
                 </a:solidFill>
-                <a:latin typeface="微软雅黑" panose="020B0503020204020204" charset="-122"/>
-                <a:ea typeface="微软雅黑" panose="020B0503020204020204" charset="-122"/>
+                <a:latin typeface="微软雅黑"/>
+                <a:ea typeface="微软雅黑"/>
               </a:rPr>
               <a:t>＋</a:t>
             </a:r>
-            <a:endParaRPr sz="2200" b="1" i="0">
-              <a:solidFill>
-                <a:srgbClr val="EACD76"/>
-              </a:solidFill>
-              <a:latin typeface="微软雅黑" panose="020B0503020204020204" charset="-122"/>
-              <a:ea typeface="微软雅黑" panose="020B0503020204020204" charset="-122"/>
-            </a:endParaRPr>
           </a:p>
         </p:txBody>
       </p:sp>
@@ -8027,18 +7640,11 @@
                 <a:solidFill>
                   <a:srgbClr val="FFFFFF"/>
                 </a:solidFill>
-                <a:latin typeface="微软雅黑" panose="020B0503020204020204" charset="-122"/>
-                <a:ea typeface="微软雅黑" panose="020B0503020204020204" charset="-122"/>
+                <a:latin typeface="微软雅黑"/>
+                <a:ea typeface="微软雅黑"/>
               </a:rPr>
               <a:t>MCP</a:t>
             </a:r>
-            <a:endParaRPr sz="2000" b="1" i="0">
-              <a:solidFill>
-                <a:srgbClr val="FFFFFF"/>
-              </a:solidFill>
-              <a:latin typeface="微软雅黑" panose="020B0503020204020204" charset="-122"/>
-              <a:ea typeface="微软雅黑" panose="020B0503020204020204" charset="-122"/>
-            </a:endParaRPr>
           </a:p>
           <a:p>
             <a:pPr algn="l">
@@ -8057,18 +7663,11 @@
                 <a:solidFill>
                   <a:srgbClr val="D6ECF0"/>
                 </a:solidFill>
-                <a:latin typeface="微软雅黑" panose="020B0503020204020204" charset="-122"/>
-                <a:ea typeface="微软雅黑" panose="020B0503020204020204" charset="-122"/>
+                <a:latin typeface="微软雅黑"/>
+                <a:ea typeface="微软雅黑"/>
               </a:rPr>
               <a:t>工具</a:t>
             </a:r>
-            <a:endParaRPr sz="1200" b="0" i="0">
-              <a:solidFill>
-                <a:srgbClr val="D6ECF0"/>
-              </a:solidFill>
-              <a:latin typeface="微软雅黑" panose="020B0503020204020204" charset="-122"/>
-              <a:ea typeface="微软雅黑" panose="020B0503020204020204" charset="-122"/>
-            </a:endParaRPr>
           </a:p>
         </p:txBody>
       </p:sp>
@@ -8110,18 +7709,11 @@
                 <a:solidFill>
                   <a:srgbClr val="50616D"/>
                 </a:solidFill>
-                <a:latin typeface="微软雅黑" panose="020B0503020204020204" charset="-122"/>
-                <a:ea typeface="微软雅黑" panose="020B0503020204020204" charset="-122"/>
+                <a:latin typeface="微软雅黑"/>
+                <a:ea typeface="微软雅黑"/>
               </a:rPr>
               <a:t>Figma / 浏览器 / 文件等外部能力 —</a:t>
             </a:r>
-            <a:endParaRPr sz="1250" b="0" i="0">
-              <a:solidFill>
-                <a:srgbClr val="50616D"/>
-              </a:solidFill>
-              <a:latin typeface="微软雅黑" panose="020B0503020204020204" charset="-122"/>
-              <a:ea typeface="微软雅黑" panose="020B0503020204020204" charset="-122"/>
-            </a:endParaRPr>
           </a:p>
           <a:p>
             <a:pPr algn="l">
@@ -8140,24 +7732,41 @@
                 <a:solidFill>
                   <a:srgbClr val="50616D"/>
                 </a:solidFill>
-                <a:latin typeface="微软雅黑" panose="020B0503020204020204" charset="-122"/>
-                <a:ea typeface="微软雅黑" panose="020B0503020204020204" charset="-122"/>
+                <a:latin typeface="微软雅黑"/>
+                <a:ea typeface="微软雅黑"/>
               </a:rPr>
               <a:t>让产物落到真实可编辑的载体上。</a:t>
             </a:r>
-            <a:endParaRPr sz="1250" b="0" i="0">
-              <a:solidFill>
-                <a:srgbClr val="50616D"/>
-              </a:solidFill>
-              <a:latin typeface="微软雅黑" panose="020B0503020204020204" charset="-122"/>
-              <a:ea typeface="微软雅黑" panose="020B0503020204020204" charset="-122"/>
-            </a:endParaRPr>
-          </a:p>
-        </p:txBody>
-      </p:sp>
-      <p:sp>
-        <p:nvSpPr>
-          <p:cNvPr id="24" name="Rectangle 23"/>
+          </a:p>
+        </p:txBody>
+      </p:sp>
+      <p:pic>
+        <p:nvPicPr>
+          <p:cNvPr id="24" name="Picture 23" descr="knot.png"/>
+          <p:cNvPicPr>
+            <a:picLocks noChangeAspect="1"/>
+          </p:cNvPicPr>
+          <p:nvPr/>
+        </p:nvPicPr>
+        <p:blipFill>
+          <a:blip r:embed="rId3"/>
+          <a:stretch>
+            <a:fillRect/>
+          </a:stretch>
+        </p:blipFill>
+        <p:spPr>
+          <a:xfrm>
+            <a:off x="10771632" y="420624"/>
+            <a:ext cx="566928" cy="566928"/>
+          </a:xfrm>
+          <a:prstGeom prst="rect">
+            <a:avLst/>
+          </a:prstGeom>
+        </p:spPr>
+      </p:pic>
+      <p:sp>
+        <p:nvSpPr>
+          <p:cNvPr id="25" name="Rectangle 24"/>
           <p:cNvSpPr/>
           <p:nvPr/>
         </p:nvSpPr>
@@ -8201,7 +7810,7 @@
       </p:sp>
       <p:sp>
         <p:nvSpPr>
-          <p:cNvPr id="25" name="Oval 24"/>
+          <p:cNvPr id="26" name="Oval 25"/>
           <p:cNvSpPr/>
           <p:nvPr/>
         </p:nvSpPr>
@@ -8245,13 +7854,13 @@
       </p:sp>
       <p:sp>
         <p:nvSpPr>
-          <p:cNvPr id="26" name="TextBox 25"/>
+          <p:cNvPr id="27" name="TextBox 26"/>
           <p:cNvSpPr txBox="1"/>
           <p:nvPr/>
         </p:nvSpPr>
         <p:spPr>
           <a:xfrm>
-            <a:off x="1729740" y="5092573"/>
+            <a:off x="1828800" y="5138928"/>
             <a:ext cx="9144000" cy="731520"/>
           </a:xfrm>
           <a:prstGeom prst="rect">
@@ -8281,8 +7890,8 @@
                 <a:solidFill>
                   <a:srgbClr val="161823"/>
                 </a:solidFill>
-                <a:latin typeface="微软雅黑" panose="020B0503020204020204" charset="-122"/>
-                <a:ea typeface="微软雅黑" panose="020B0503020204020204" charset="-122"/>
+                <a:latin typeface="微软雅黑"/>
+                <a:ea typeface="微软雅黑"/>
               </a:rPr>
               <a:t>一句话：装好技能后，通常只需 </a:t>
             </a:r>
@@ -8291,8 +7900,8 @@
                 <a:solidFill>
                   <a:srgbClr val="065279"/>
                 </a:solidFill>
-                <a:latin typeface="楷体" panose="02010609060101010101" charset="-122"/>
-                <a:ea typeface="楷体" panose="02010609060101010101" charset="-122"/>
+                <a:latin typeface="楷体"/>
+                <a:ea typeface="楷体"/>
               </a:rPr>
               <a:t>「$my-design-style 帮我做一份…」</a:t>
             </a:r>
@@ -8301,18 +7910,11 @@
                 <a:solidFill>
                   <a:srgbClr val="161823"/>
                 </a:solidFill>
-                <a:latin typeface="微软雅黑" panose="020B0503020204020204" charset="-122"/>
-                <a:ea typeface="微软雅黑" panose="020B0503020204020204" charset="-122"/>
+                <a:latin typeface="微软雅黑"/>
+                <a:ea typeface="微软雅黑"/>
               </a:rPr>
               <a:t> 触发，智能体会自动调度其余环节。</a:t>
             </a:r>
-            <a:endParaRPr sz="1300" b="0" i="0">
-              <a:solidFill>
-                <a:srgbClr val="161823"/>
-              </a:solidFill>
-              <a:latin typeface="微软雅黑" panose="020B0503020204020204" charset="-122"/>
-              <a:ea typeface="微软雅黑" panose="020B0503020204020204" charset="-122"/>
-            </a:endParaRPr>
           </a:p>
         </p:txBody>
       </p:sp>
@@ -8325,7 +7927,7 @@
 </file>
 
 <file path=ppt/slides/slide5.xml><?xml version="1.0" encoding="utf-8"?>
-<p:sld xmlns:a="http://schemas.openxmlformats.org/drawingml/2006/main" xmlns:r="http://schemas.openxmlformats.org/officeDocument/2006/relationships" xmlns:p="http://schemas.openxmlformats.org/presentationml/2006/main">
+<p:sld xmlns:a="http://schemas.openxmlformats.org/drawingml/2006/main" xmlns:p="http://schemas.openxmlformats.org/presentationml/2006/main" xmlns:r="http://schemas.openxmlformats.org/officeDocument/2006/relationships">
   <p:cSld>
     <p:bg>
       <p:bgPr>
@@ -8344,14 +7946,14 @@
       <p:grpSpPr/>
       <p:pic>
         <p:nvPicPr>
-          <p:cNvPr id="2" name="Picture 1" descr="paper_texture.png"/>
+          <p:cNvPr id="2" name="Picture 1" descr="rice_paper_bg.png"/>
           <p:cNvPicPr>
             <a:picLocks noChangeAspect="1"/>
           </p:cNvPicPr>
           <p:nvPr/>
         </p:nvPicPr>
         <p:blipFill>
-          <a:blip r:embed="rId1"/>
+          <a:blip r:embed="rId2"/>
           <a:stretch>
             <a:fillRect/>
           </a:stretch>
@@ -8462,7 +8064,7 @@
         </p:nvSpPr>
         <p:spPr>
           <a:xfrm>
-            <a:off x="475615" y="621919"/>
+            <a:off x="640080" y="603504"/>
             <a:ext cx="548640" cy="457200"/>
           </a:xfrm>
           <a:prstGeom prst="rect">
@@ -8492,18 +8094,11 @@
                 <a:solidFill>
                   <a:srgbClr val="FFFBF0"/>
                 </a:solidFill>
-                <a:latin typeface="宋体" panose="02010600030101010101" pitchFamily="2" charset="-122"/>
-                <a:ea typeface="宋体" panose="02010600030101010101" pitchFamily="2" charset="-122"/>
+                <a:latin typeface="宋体"/>
+                <a:ea typeface="宋体"/>
               </a:rPr>
               <a:t>选</a:t>
             </a:r>
-            <a:endParaRPr sz="1500" b="1" i="0">
-              <a:solidFill>
-                <a:srgbClr val="FFFBF0"/>
-              </a:solidFill>
-              <a:latin typeface="宋体" panose="02010600030101010101" pitchFamily="2" charset="-122"/>
-              <a:ea typeface="宋体" panose="02010600030101010101" pitchFamily="2" charset="-122"/>
-            </a:endParaRPr>
           </a:p>
         </p:txBody>
       </p:sp>
@@ -8545,18 +8140,11 @@
                 <a:solidFill>
                   <a:srgbClr val="161823"/>
                 </a:solidFill>
-                <a:latin typeface="宋体" panose="02010600030101010101" pitchFamily="2" charset="-122"/>
-                <a:ea typeface="宋体" panose="02010600030101010101" pitchFamily="2" charset="-122"/>
+                <a:latin typeface="宋体"/>
+                <a:ea typeface="宋体"/>
               </a:rPr>
               <a:t>选型建议 · 智能体与大模型</a:t>
             </a:r>
-            <a:endParaRPr sz="2700" b="1" i="0">
-              <a:solidFill>
-                <a:srgbClr val="161823"/>
-              </a:solidFill>
-              <a:latin typeface="宋体" panose="02010600030101010101" pitchFamily="2" charset="-122"/>
-              <a:ea typeface="宋体" panose="02010600030101010101" pitchFamily="2" charset="-122"/>
-            </a:endParaRPr>
           </a:p>
         </p:txBody>
       </p:sp>
@@ -8598,18 +8186,11 @@
                 <a:solidFill>
                   <a:srgbClr val="177CB0"/>
                 </a:solidFill>
-                <a:latin typeface="微软雅黑" panose="020B0503020204020204" charset="-122"/>
-                <a:ea typeface="微软雅黑" panose="020B0503020204020204" charset="-122"/>
+                <a:latin typeface="微软雅黑"/>
+                <a:ea typeface="微软雅黑"/>
               </a:rPr>
               <a:t>WHAT TO RUN — AS OF 2026</a:t>
             </a:r>
-            <a:endParaRPr sz="1200" b="0" i="0">
-              <a:solidFill>
-                <a:srgbClr val="177CB0"/>
-              </a:solidFill>
-              <a:latin typeface="微软雅黑" panose="020B0503020204020204" charset="-122"/>
-              <a:ea typeface="微软雅黑" panose="020B0503020204020204" charset="-122"/>
-            </a:endParaRPr>
           </a:p>
         </p:txBody>
       </p:sp>
@@ -8777,18 +8358,11 @@
                 <a:solidFill>
                   <a:srgbClr val="FFFFFF"/>
                 </a:solidFill>
-                <a:latin typeface="微软雅黑" panose="020B0503020204020204" charset="-122"/>
-                <a:ea typeface="微软雅黑" panose="020B0503020204020204" charset="-122"/>
+                <a:latin typeface="微软雅黑"/>
+                <a:ea typeface="微软雅黑"/>
               </a:rPr>
               <a:t>智能体 Agent</a:t>
             </a:r>
-            <a:endParaRPr sz="1700" b="1" i="0">
-              <a:solidFill>
-                <a:srgbClr val="FFFFFF"/>
-              </a:solidFill>
-              <a:latin typeface="微软雅黑" panose="020B0503020204020204" charset="-122"/>
-              <a:ea typeface="微软雅黑" panose="020B0503020204020204" charset="-122"/>
-            </a:endParaRPr>
           </a:p>
         </p:txBody>
       </p:sp>
@@ -8874,18 +8448,11 @@
                 <a:solidFill>
                   <a:srgbClr val="161823"/>
                 </a:solidFill>
-                <a:latin typeface="微软雅黑" panose="020B0503020204020204" charset="-122"/>
-                <a:ea typeface="微软雅黑" panose="020B0503020204020204" charset="-122"/>
+                <a:latin typeface="微软雅黑"/>
+                <a:ea typeface="微软雅黑"/>
               </a:rPr>
               <a:t>Claude Code</a:t>
             </a:r>
-            <a:endParaRPr sz="1400" b="1" i="0">
-              <a:solidFill>
-                <a:srgbClr val="161823"/>
-              </a:solidFill>
-              <a:latin typeface="微软雅黑" panose="020B0503020204020204" charset="-122"/>
-              <a:ea typeface="微软雅黑" panose="020B0503020204020204" charset="-122"/>
-            </a:endParaRPr>
           </a:p>
         </p:txBody>
       </p:sp>
@@ -8927,18 +8494,11 @@
                 <a:solidFill>
                   <a:srgbClr val="50616D"/>
                 </a:solidFill>
-                <a:latin typeface="微软雅黑" panose="020B0503020204020204" charset="-122"/>
-                <a:ea typeface="微软雅黑" panose="020B0503020204020204" charset="-122"/>
+                <a:latin typeface="微软雅黑"/>
+                <a:ea typeface="微软雅黑"/>
               </a:rPr>
               <a:t>终端原生、技能与 MCP 生态成熟</a:t>
             </a:r>
-            <a:endParaRPr sz="1150" b="0" i="0">
-              <a:solidFill>
-                <a:srgbClr val="50616D"/>
-              </a:solidFill>
-              <a:latin typeface="微软雅黑" panose="020B0503020204020204" charset="-122"/>
-              <a:ea typeface="微软雅黑" panose="020B0503020204020204" charset="-122"/>
-            </a:endParaRPr>
           </a:p>
         </p:txBody>
       </p:sp>
@@ -9024,18 +8584,11 @@
                 <a:solidFill>
                   <a:srgbClr val="161823"/>
                 </a:solidFill>
-                <a:latin typeface="微软雅黑" panose="020B0503020204020204" charset="-122"/>
-                <a:ea typeface="微软雅黑" panose="020B0503020204020204" charset="-122"/>
+                <a:latin typeface="微软雅黑"/>
+                <a:ea typeface="微软雅黑"/>
               </a:rPr>
               <a:t>Codex</a:t>
             </a:r>
-            <a:endParaRPr sz="1400" b="1" i="0">
-              <a:solidFill>
-                <a:srgbClr val="161823"/>
-              </a:solidFill>
-              <a:latin typeface="微软雅黑" panose="020B0503020204020204" charset="-122"/>
-              <a:ea typeface="微软雅黑" panose="020B0503020204020204" charset="-122"/>
-            </a:endParaRPr>
           </a:p>
         </p:txBody>
       </p:sp>
@@ -9077,18 +8630,11 @@
                 <a:solidFill>
                   <a:srgbClr val="50616D"/>
                 </a:solidFill>
-                <a:latin typeface="微软雅黑" panose="020B0503020204020204" charset="-122"/>
-                <a:ea typeface="微软雅黑" panose="020B0503020204020204" charset="-122"/>
+                <a:latin typeface="微软雅黑"/>
+                <a:ea typeface="微软雅黑"/>
               </a:rPr>
               <a:t>本仓库演示资源的产出工具</a:t>
             </a:r>
-            <a:endParaRPr sz="1150" b="0" i="0">
-              <a:solidFill>
-                <a:srgbClr val="50616D"/>
-              </a:solidFill>
-              <a:latin typeface="微软雅黑" panose="020B0503020204020204" charset="-122"/>
-              <a:ea typeface="微软雅黑" panose="020B0503020204020204" charset="-122"/>
-            </a:endParaRPr>
           </a:p>
         </p:txBody>
       </p:sp>
@@ -9174,18 +8720,11 @@
                 <a:solidFill>
                   <a:srgbClr val="161823"/>
                 </a:solidFill>
-                <a:latin typeface="微软雅黑" panose="020B0503020204020204" charset="-122"/>
-                <a:ea typeface="微软雅黑" panose="020B0503020204020204" charset="-122"/>
+                <a:latin typeface="微软雅黑"/>
+                <a:ea typeface="微软雅黑"/>
               </a:rPr>
               <a:t>Cursor</a:t>
             </a:r>
-            <a:endParaRPr sz="1400" b="1" i="0">
-              <a:solidFill>
-                <a:srgbClr val="161823"/>
-              </a:solidFill>
-              <a:latin typeface="微软雅黑" panose="020B0503020204020204" charset="-122"/>
-              <a:ea typeface="微软雅黑" panose="020B0503020204020204" charset="-122"/>
-            </a:endParaRPr>
           </a:p>
         </p:txBody>
       </p:sp>
@@ -9227,18 +8766,11 @@
                 <a:solidFill>
                   <a:srgbClr val="50616D"/>
                 </a:solidFill>
-                <a:latin typeface="微软雅黑" panose="020B0503020204020204" charset="-122"/>
-                <a:ea typeface="微软雅黑" panose="020B0503020204020204" charset="-122"/>
+                <a:latin typeface="微软雅黑"/>
+                <a:ea typeface="微软雅黑"/>
               </a:rPr>
               <a:t>编辑器内交互，适合边写边看</a:t>
             </a:r>
-            <a:endParaRPr sz="1150" b="0" i="0">
-              <a:solidFill>
-                <a:srgbClr val="50616D"/>
-              </a:solidFill>
-              <a:latin typeface="微软雅黑" panose="020B0503020204020204" charset="-122"/>
-              <a:ea typeface="微软雅黑" panose="020B0503020204020204" charset="-122"/>
-            </a:endParaRPr>
           </a:p>
         </p:txBody>
       </p:sp>
@@ -9370,18 +8902,11 @@
                 <a:solidFill>
                   <a:srgbClr val="FFFFFF"/>
                 </a:solidFill>
-                <a:latin typeface="微软雅黑" panose="020B0503020204020204" charset="-122"/>
-                <a:ea typeface="微软雅黑" panose="020B0503020204020204" charset="-122"/>
+                <a:latin typeface="微软雅黑"/>
+                <a:ea typeface="微软雅黑"/>
               </a:rPr>
               <a:t>大模型 LLM · 推荐档位</a:t>
             </a:r>
-            <a:endParaRPr sz="1700" b="1" i="0">
-              <a:solidFill>
-                <a:srgbClr val="FFFFFF"/>
-              </a:solidFill>
-              <a:latin typeface="微软雅黑" panose="020B0503020204020204" charset="-122"/>
-              <a:ea typeface="微软雅黑" panose="020B0503020204020204" charset="-122"/>
-            </a:endParaRPr>
           </a:p>
         </p:txBody>
       </p:sp>
@@ -9467,18 +8992,11 @@
                 <a:solidFill>
                   <a:srgbClr val="065279"/>
                 </a:solidFill>
-                <a:latin typeface="微软雅黑" panose="020B0503020204020204" charset="-122"/>
-                <a:ea typeface="微软雅黑" panose="020B0503020204020204" charset="-122"/>
+                <a:latin typeface="微软雅黑"/>
+                <a:ea typeface="微软雅黑"/>
               </a:rPr>
               <a:t>GPT-5.5+</a:t>
             </a:r>
-            <a:endParaRPr sz="1450" b="1" i="0">
-              <a:solidFill>
-                <a:srgbClr val="065279"/>
-              </a:solidFill>
-              <a:latin typeface="微软雅黑" panose="020B0503020204020204" charset="-122"/>
-              <a:ea typeface="微软雅黑" panose="020B0503020204020204" charset="-122"/>
-            </a:endParaRPr>
           </a:p>
         </p:txBody>
       </p:sp>
@@ -9564,18 +9082,11 @@
                 <a:solidFill>
                   <a:srgbClr val="065279"/>
                 </a:solidFill>
-                <a:latin typeface="微软雅黑" panose="020B0503020204020204" charset="-122"/>
-                <a:ea typeface="微软雅黑" panose="020B0503020204020204" charset="-122"/>
+                <a:latin typeface="微软雅黑"/>
+                <a:ea typeface="微软雅黑"/>
               </a:rPr>
               <a:t>Claude 4.6+</a:t>
             </a:r>
-            <a:endParaRPr sz="1450" b="1" i="0">
-              <a:solidFill>
-                <a:srgbClr val="065279"/>
-              </a:solidFill>
-              <a:latin typeface="微软雅黑" panose="020B0503020204020204" charset="-122"/>
-              <a:ea typeface="微软雅黑" panose="020B0503020204020204" charset="-122"/>
-            </a:endParaRPr>
           </a:p>
         </p:txBody>
       </p:sp>
@@ -9661,18 +9172,11 @@
                 <a:solidFill>
                   <a:srgbClr val="065279"/>
                 </a:solidFill>
-                <a:latin typeface="微软雅黑" panose="020B0503020204020204" charset="-122"/>
-                <a:ea typeface="微软雅黑" panose="020B0503020204020204" charset="-122"/>
+                <a:latin typeface="微软雅黑"/>
+                <a:ea typeface="微软雅黑"/>
               </a:rPr>
               <a:t>Gemini</a:t>
             </a:r>
-            <a:endParaRPr sz="1450" b="1" i="0">
-              <a:solidFill>
-                <a:srgbClr val="065279"/>
-              </a:solidFill>
-              <a:latin typeface="微软雅黑" panose="020B0503020204020204" charset="-122"/>
-              <a:ea typeface="微软雅黑" panose="020B0503020204020204" charset="-122"/>
-            </a:endParaRPr>
           </a:p>
         </p:txBody>
       </p:sp>
@@ -9758,18 +9262,11 @@
                 <a:solidFill>
                   <a:srgbClr val="065279"/>
                 </a:solidFill>
-                <a:latin typeface="微软雅黑" panose="020B0503020204020204" charset="-122"/>
-                <a:ea typeface="微软雅黑" panose="020B0503020204020204" charset="-122"/>
+                <a:latin typeface="微软雅黑"/>
+                <a:ea typeface="微软雅黑"/>
               </a:rPr>
               <a:t>Qwen Max</a:t>
             </a:r>
-            <a:endParaRPr sz="1450" b="1" i="0">
-              <a:solidFill>
-                <a:srgbClr val="065279"/>
-              </a:solidFill>
-              <a:latin typeface="微软雅黑" panose="020B0503020204020204" charset="-122"/>
-              <a:ea typeface="微软雅黑" panose="020B0503020204020204" charset="-122"/>
-            </a:endParaRPr>
           </a:p>
         </p:txBody>
       </p:sp>
@@ -9811,18 +9308,11 @@
                 <a:solidFill>
                   <a:srgbClr val="50616D"/>
                 </a:solidFill>
-                <a:latin typeface="微软雅黑" panose="020B0503020204020204" charset="-122"/>
-                <a:ea typeface="微软雅黑" panose="020B0503020204020204" charset="-122"/>
+                <a:latin typeface="微软雅黑"/>
+                <a:ea typeface="微软雅黑"/>
               </a:rPr>
               <a:t>产物审美高度依赖模型档位；低于此档位，</a:t>
             </a:r>
-            <a:endParaRPr sz="1100" b="0" i="0">
-              <a:solidFill>
-                <a:srgbClr val="50616D"/>
-              </a:solidFill>
-              <a:latin typeface="微软雅黑" panose="020B0503020204020204" charset="-122"/>
-              <a:ea typeface="微软雅黑" panose="020B0503020204020204" charset="-122"/>
-            </a:endParaRPr>
           </a:p>
           <a:p>
             <a:pPr algn="l">
@@ -9841,18 +9331,11 @@
                 <a:solidFill>
                   <a:srgbClr val="50616D"/>
                 </a:solidFill>
-                <a:latin typeface="微软雅黑" panose="020B0503020204020204" charset="-122"/>
-                <a:ea typeface="微软雅黑" panose="020B0503020204020204" charset="-122"/>
+                <a:latin typeface="微软雅黑"/>
+                <a:ea typeface="微软雅黑"/>
               </a:rPr>
               <a:t>成稿质量会明显下滑。</a:t>
             </a:r>
-            <a:endParaRPr sz="1100" b="0" i="0">
-              <a:solidFill>
-                <a:srgbClr val="50616D"/>
-              </a:solidFill>
-              <a:latin typeface="微软雅黑" panose="020B0503020204020204" charset="-122"/>
-              <a:ea typeface="微软雅黑" panose="020B0503020204020204" charset="-122"/>
-            </a:endParaRPr>
           </a:p>
         </p:txBody>
       </p:sp>
@@ -9865,7 +9348,7 @@
 </file>
 
 <file path=ppt/slides/slide6.xml><?xml version="1.0" encoding="utf-8"?>
-<p:sld xmlns:a="http://schemas.openxmlformats.org/drawingml/2006/main" xmlns:r="http://schemas.openxmlformats.org/officeDocument/2006/relationships" xmlns:p="http://schemas.openxmlformats.org/presentationml/2006/main">
+<p:sld xmlns:a="http://schemas.openxmlformats.org/drawingml/2006/main" xmlns:p="http://schemas.openxmlformats.org/presentationml/2006/main" xmlns:r="http://schemas.openxmlformats.org/officeDocument/2006/relationships">
   <p:cSld>
     <p:bg>
       <p:bgPr>
@@ -9884,14 +9367,14 @@
       <p:grpSpPr/>
       <p:pic>
         <p:nvPicPr>
-          <p:cNvPr id="2" name="Picture 1" descr="paper_texture.png"/>
+          <p:cNvPr id="2" name="Picture 1" descr="rice_paper_bg.png"/>
           <p:cNvPicPr>
             <a:picLocks noChangeAspect="1"/>
           </p:cNvPicPr>
           <p:nvPr/>
         </p:nvPicPr>
         <p:blipFill>
-          <a:blip r:embed="rId1"/>
+          <a:blip r:embed="rId2"/>
           <a:stretch>
             <a:fillRect/>
           </a:stretch>
@@ -10002,7 +9485,7 @@
         </p:nvSpPr>
         <p:spPr>
           <a:xfrm>
-            <a:off x="475615" y="621919"/>
+            <a:off x="640080" y="603504"/>
             <a:ext cx="548640" cy="457200"/>
           </a:xfrm>
           <a:prstGeom prst="rect">
@@ -10032,18 +9515,11 @@
                 <a:solidFill>
                   <a:srgbClr val="FFFBF0"/>
                 </a:solidFill>
-                <a:latin typeface="宋体" panose="02010600030101010101" pitchFamily="2" charset="-122"/>
-                <a:ea typeface="宋体" panose="02010600030101010101" pitchFamily="2" charset="-122"/>
+                <a:latin typeface="宋体"/>
+                <a:ea typeface="宋体"/>
               </a:rPr>
               <a:t>装</a:t>
             </a:r>
-            <a:endParaRPr sz="1500" b="1" i="0">
-              <a:solidFill>
-                <a:srgbClr val="FFFBF0"/>
-              </a:solidFill>
-              <a:latin typeface="宋体" panose="02010600030101010101" pitchFamily="2" charset="-122"/>
-              <a:ea typeface="宋体" panose="02010600030101010101" pitchFamily="2" charset="-122"/>
-            </a:endParaRPr>
           </a:p>
         </p:txBody>
       </p:sp>
@@ -10085,18 +9561,11 @@
                 <a:solidFill>
                   <a:srgbClr val="161823"/>
                 </a:solidFill>
-                <a:latin typeface="宋体" panose="02010600030101010101" pitchFamily="2" charset="-122"/>
-                <a:ea typeface="宋体" panose="02010600030101010101" pitchFamily="2" charset="-122"/>
+                <a:latin typeface="宋体"/>
+                <a:ea typeface="宋体"/>
               </a:rPr>
               <a:t>安装与调用 · 三步上手</a:t>
             </a:r>
-            <a:endParaRPr sz="2700" b="1" i="0">
-              <a:solidFill>
-                <a:srgbClr val="161823"/>
-              </a:solidFill>
-              <a:latin typeface="宋体" panose="02010600030101010101" pitchFamily="2" charset="-122"/>
-              <a:ea typeface="宋体" panose="02010600030101010101" pitchFamily="2" charset="-122"/>
-            </a:endParaRPr>
           </a:p>
         </p:txBody>
       </p:sp>
@@ -10138,18 +9607,11 @@
                 <a:solidFill>
                   <a:srgbClr val="177CB0"/>
                 </a:solidFill>
-                <a:latin typeface="微软雅黑" panose="020B0503020204020204" charset="-122"/>
-                <a:ea typeface="微软雅黑" panose="020B0503020204020204" charset="-122"/>
+                <a:latin typeface="微软雅黑"/>
+                <a:ea typeface="微软雅黑"/>
               </a:rPr>
               <a:t>INSTALL &amp; INVOKE</a:t>
             </a:r>
-            <a:endParaRPr sz="1200" b="0" i="0">
-              <a:solidFill>
-                <a:srgbClr val="177CB0"/>
-              </a:solidFill>
-              <a:latin typeface="微软雅黑" panose="020B0503020204020204" charset="-122"/>
-              <a:ea typeface="微软雅黑" panose="020B0503020204020204" charset="-122"/>
-            </a:endParaRPr>
           </a:p>
         </p:txBody>
       </p:sp>
@@ -10317,18 +9779,11 @@
                 <a:solidFill>
                   <a:srgbClr val="FFFFFF"/>
                 </a:solidFill>
-                <a:latin typeface="宋体" panose="02010600030101010101" pitchFamily="2" charset="-122"/>
-                <a:ea typeface="宋体" panose="02010600030101010101" pitchFamily="2" charset="-122"/>
+                <a:latin typeface="宋体"/>
+                <a:ea typeface="宋体"/>
               </a:rPr>
               <a:t>1</a:t>
             </a:r>
-            <a:endParaRPr sz="3000" b="1" i="0">
-              <a:solidFill>
-                <a:srgbClr val="FFFFFF"/>
-              </a:solidFill>
-              <a:latin typeface="宋体" panose="02010600030101010101" pitchFamily="2" charset="-122"/>
-              <a:ea typeface="宋体" panose="02010600030101010101" pitchFamily="2" charset="-122"/>
-            </a:endParaRPr>
           </a:p>
         </p:txBody>
       </p:sp>
@@ -10370,18 +9825,11 @@
                 <a:solidFill>
                   <a:srgbClr val="161823"/>
                 </a:solidFill>
-                <a:latin typeface="微软雅黑" panose="020B0503020204020204" charset="-122"/>
-                <a:ea typeface="微软雅黑" panose="020B0503020204020204" charset="-122"/>
+                <a:latin typeface="微软雅黑"/>
+                <a:ea typeface="微软雅黑"/>
               </a:rPr>
               <a:t>拿到技能</a:t>
             </a:r>
-            <a:endParaRPr sz="1650" b="1" i="0">
-              <a:solidFill>
-                <a:srgbClr val="161823"/>
-              </a:solidFill>
-              <a:latin typeface="微软雅黑" panose="020B0503020204020204" charset="-122"/>
-              <a:ea typeface="微软雅黑" panose="020B0503020204020204" charset="-122"/>
-            </a:endParaRPr>
           </a:p>
           <a:p>
             <a:pPr algn="l">
@@ -10400,18 +9848,11 @@
                 <a:solidFill>
                   <a:srgbClr val="50616D"/>
                 </a:solidFill>
-                <a:latin typeface="微软雅黑" panose="020B0503020204020204" charset="-122"/>
-                <a:ea typeface="微软雅黑" panose="020B0503020204020204" charset="-122"/>
+                <a:latin typeface="微软雅黑"/>
+                <a:ea typeface="微软雅黑"/>
               </a:rPr>
               <a:t>把 skill 文件夹放到本地，或给智能体一个可下载链接，让它替你安装到环境的 skills 目录。</a:t>
             </a:r>
-            <a:endParaRPr sz="1250" b="0" i="0">
-              <a:solidFill>
-                <a:srgbClr val="50616D"/>
-              </a:solidFill>
-              <a:latin typeface="微软雅黑" panose="020B0503020204020204" charset="-122"/>
-              <a:ea typeface="微软雅黑" panose="020B0503020204020204" charset="-122"/>
-            </a:endParaRPr>
           </a:p>
         </p:txBody>
       </p:sp>
@@ -10543,18 +9984,11 @@
                 <a:solidFill>
                   <a:srgbClr val="FFFFFF"/>
                 </a:solidFill>
-                <a:latin typeface="宋体" panose="02010600030101010101" pitchFamily="2" charset="-122"/>
-                <a:ea typeface="宋体" panose="02010600030101010101" pitchFamily="2" charset="-122"/>
+                <a:latin typeface="宋体"/>
+                <a:ea typeface="宋体"/>
               </a:rPr>
               <a:t>2</a:t>
             </a:r>
-            <a:endParaRPr sz="3000" b="1" i="0">
-              <a:solidFill>
-                <a:srgbClr val="FFFFFF"/>
-              </a:solidFill>
-              <a:latin typeface="宋体" panose="02010600030101010101" pitchFamily="2" charset="-122"/>
-              <a:ea typeface="宋体" panose="02010600030101010101" pitchFamily="2" charset="-122"/>
-            </a:endParaRPr>
           </a:p>
         </p:txBody>
       </p:sp>
@@ -10596,18 +10030,11 @@
                 <a:solidFill>
                   <a:srgbClr val="161823"/>
                 </a:solidFill>
-                <a:latin typeface="微软雅黑" panose="020B0503020204020204" charset="-122"/>
-                <a:ea typeface="微软雅黑" panose="020B0503020204020204" charset="-122"/>
+                <a:latin typeface="微软雅黑"/>
+                <a:ea typeface="微软雅黑"/>
               </a:rPr>
               <a:t>确认就位</a:t>
             </a:r>
-            <a:endParaRPr sz="1650" b="1" i="0">
-              <a:solidFill>
-                <a:srgbClr val="161823"/>
-              </a:solidFill>
-              <a:latin typeface="微软雅黑" panose="020B0503020204020204" charset="-122"/>
-              <a:ea typeface="微软雅黑" panose="020B0503020204020204" charset="-122"/>
-            </a:endParaRPr>
           </a:p>
           <a:p>
             <a:pPr algn="l">
@@ -10626,18 +10053,11 @@
                 <a:solidFill>
                   <a:srgbClr val="50616D"/>
                 </a:solidFill>
-                <a:latin typeface="微软雅黑" panose="020B0503020204020204" charset="-122"/>
-                <a:ea typeface="微软雅黑" panose="020B0503020204020204" charset="-122"/>
+                <a:latin typeface="微软雅黑"/>
+                <a:ea typeface="微软雅黑"/>
               </a:rPr>
               <a:t>智能体读取 SKILL.md 与 references，识别可用风格；本篇即用 chinese_traditional_color_style。</a:t>
             </a:r>
-            <a:endParaRPr sz="1250" b="0" i="0">
-              <a:solidFill>
-                <a:srgbClr val="50616D"/>
-              </a:solidFill>
-              <a:latin typeface="微软雅黑" panose="020B0503020204020204" charset="-122"/>
-              <a:ea typeface="微软雅黑" panose="020B0503020204020204" charset="-122"/>
-            </a:endParaRPr>
           </a:p>
         </p:txBody>
       </p:sp>
@@ -10769,18 +10189,11 @@
                 <a:solidFill>
                   <a:srgbClr val="FFFFFF"/>
                 </a:solidFill>
-                <a:latin typeface="宋体" panose="02010600030101010101" pitchFamily="2" charset="-122"/>
-                <a:ea typeface="宋体" panose="02010600030101010101" pitchFamily="2" charset="-122"/>
+                <a:latin typeface="宋体"/>
+                <a:ea typeface="宋体"/>
               </a:rPr>
               <a:t>3</a:t>
             </a:r>
-            <a:endParaRPr sz="3000" b="1" i="0">
-              <a:solidFill>
-                <a:srgbClr val="FFFFFF"/>
-              </a:solidFill>
-              <a:latin typeface="宋体" panose="02010600030101010101" pitchFamily="2" charset="-122"/>
-              <a:ea typeface="宋体" panose="02010600030101010101" pitchFamily="2" charset="-122"/>
-            </a:endParaRPr>
           </a:p>
         </p:txBody>
       </p:sp>
@@ -10822,18 +10235,11 @@
                 <a:solidFill>
                   <a:srgbClr val="161823"/>
                 </a:solidFill>
-                <a:latin typeface="微软雅黑" panose="020B0503020204020204" charset="-122"/>
-                <a:ea typeface="微软雅黑" panose="020B0503020204020204" charset="-122"/>
+                <a:latin typeface="微软雅黑"/>
+                <a:ea typeface="微软雅黑"/>
               </a:rPr>
               <a:t>精确触发</a:t>
             </a:r>
-            <a:endParaRPr sz="1650" b="1" i="0">
-              <a:solidFill>
-                <a:srgbClr val="161823"/>
-              </a:solidFill>
-              <a:latin typeface="微软雅黑" panose="020B0503020204020204" charset="-122"/>
-              <a:ea typeface="微软雅黑" panose="020B0503020204020204" charset="-122"/>
-            </a:endParaRPr>
           </a:p>
           <a:p>
             <a:pPr algn="l">
@@ -10852,18 +10258,11 @@
                 <a:solidFill>
                   <a:srgbClr val="50616D"/>
                 </a:solidFill>
-                <a:latin typeface="微软雅黑" panose="020B0503020204020204" charset="-122"/>
-                <a:ea typeface="微软雅黑" panose="020B0503020204020204" charset="-122"/>
+                <a:latin typeface="微软雅黑"/>
+                <a:ea typeface="微软雅黑"/>
               </a:rPr>
               <a:t>用「$技能名」点名调用最精确。多数时候智能体也会按任务自动调用，点名只是更稳。</a:t>
             </a:r>
-            <a:endParaRPr sz="1250" b="0" i="0">
-              <a:solidFill>
-                <a:srgbClr val="50616D"/>
-              </a:solidFill>
-              <a:latin typeface="微软雅黑" panose="020B0503020204020204" charset="-122"/>
-              <a:ea typeface="微软雅黑" panose="020B0503020204020204" charset="-122"/>
-            </a:endParaRPr>
           </a:p>
         </p:txBody>
       </p:sp>
@@ -10949,18 +10348,11 @@
                 <a:solidFill>
                   <a:srgbClr val="D6ECF0"/>
                 </a:solidFill>
-                <a:latin typeface="楷体" panose="02010609060101010101" charset="-122"/>
-                <a:ea typeface="楷体" panose="02010609060101010101" charset="-122"/>
+                <a:latin typeface="楷体"/>
+                <a:ea typeface="楷体"/>
               </a:rPr>
               <a:t>›  $my-design-style  请用中国传统色风格，做一份介绍本工作流的 PPT</a:t>
             </a:r>
-            <a:endParaRPr sz="1300" b="0" i="0">
-              <a:solidFill>
-                <a:srgbClr val="D6ECF0"/>
-              </a:solidFill>
-              <a:latin typeface="楷体" panose="02010609060101010101" charset="-122"/>
-              <a:ea typeface="楷体" panose="02010609060101010101" charset="-122"/>
-            </a:endParaRPr>
           </a:p>
         </p:txBody>
       </p:sp>
@@ -10973,7 +10365,7 @@
 </file>
 
 <file path=ppt/slides/slide7.xml><?xml version="1.0" encoding="utf-8"?>
-<p:sld xmlns:a="http://schemas.openxmlformats.org/drawingml/2006/main" xmlns:r="http://schemas.openxmlformats.org/officeDocument/2006/relationships" xmlns:p="http://schemas.openxmlformats.org/presentationml/2006/main">
+<p:sld xmlns:a="http://schemas.openxmlformats.org/drawingml/2006/main" xmlns:p="http://schemas.openxmlformats.org/presentationml/2006/main" xmlns:r="http://schemas.openxmlformats.org/officeDocument/2006/relationships">
   <p:cSld>
     <p:bg>
       <p:bgPr>
@@ -10992,14 +10384,14 @@
       <p:grpSpPr/>
       <p:pic>
         <p:nvPicPr>
-          <p:cNvPr id="2" name="Picture 1" descr="paper_texture.png"/>
+          <p:cNvPr id="2" name="Picture 1" descr="rice_paper_bg.png"/>
           <p:cNvPicPr>
             <a:picLocks noChangeAspect="1"/>
           </p:cNvPicPr>
           <p:nvPr/>
         </p:nvPicPr>
         <p:blipFill>
-          <a:blip r:embed="rId1"/>
+          <a:blip r:embed="rId2"/>
           <a:stretch>
             <a:fillRect/>
           </a:stretch>
@@ -11110,7 +10502,7 @@
         </p:nvSpPr>
         <p:spPr>
           <a:xfrm>
-            <a:off x="475615" y="621919"/>
+            <a:off x="640080" y="603504"/>
             <a:ext cx="548640" cy="457200"/>
           </a:xfrm>
           <a:prstGeom prst="rect">
@@ -11140,18 +10532,11 @@
                 <a:solidFill>
                   <a:srgbClr val="FFFBF0"/>
                 </a:solidFill>
-                <a:latin typeface="宋体" panose="02010600030101010101" pitchFamily="2" charset="-122"/>
-                <a:ea typeface="宋体" panose="02010600030101010101" pitchFamily="2" charset="-122"/>
+                <a:latin typeface="宋体"/>
+                <a:ea typeface="宋体"/>
               </a:rPr>
               <a:t>产</a:t>
             </a:r>
-            <a:endParaRPr sz="1500" b="1" i="0">
-              <a:solidFill>
-                <a:srgbClr val="FFFBF0"/>
-              </a:solidFill>
-              <a:latin typeface="宋体" panose="02010600030101010101" pitchFamily="2" charset="-122"/>
-              <a:ea typeface="宋体" panose="02010600030101010101" pitchFamily="2" charset="-122"/>
-            </a:endParaRPr>
           </a:p>
         </p:txBody>
       </p:sp>
@@ -11193,18 +10578,11 @@
                 <a:solidFill>
                   <a:srgbClr val="161823"/>
                 </a:solidFill>
-                <a:latin typeface="宋体" panose="02010600030101010101" pitchFamily="2" charset="-122"/>
-                <a:ea typeface="宋体" panose="02010600030101010101" pitchFamily="2" charset="-122"/>
+                <a:latin typeface="宋体"/>
+                <a:ea typeface="宋体"/>
               </a:rPr>
               <a:t>产物与格式 · 要「可编辑」</a:t>
             </a:r>
-            <a:endParaRPr sz="2700" b="1" i="0">
-              <a:solidFill>
-                <a:srgbClr val="161823"/>
-              </a:solidFill>
-              <a:latin typeface="宋体" panose="02010600030101010101" pitchFamily="2" charset="-122"/>
-              <a:ea typeface="宋体" panose="02010600030101010101" pitchFamily="2" charset="-122"/>
-            </a:endParaRPr>
           </a:p>
         </p:txBody>
       </p:sp>
@@ -11246,18 +10624,11 @@
                 <a:solidFill>
                   <a:srgbClr val="177CB0"/>
                 </a:solidFill>
-                <a:latin typeface="微软雅黑" panose="020B0503020204020204" charset="-122"/>
-                <a:ea typeface="微软雅黑" panose="020B0503020204020204" charset="-122"/>
+                <a:latin typeface="微软雅黑"/>
+                <a:ea typeface="微软雅黑"/>
               </a:rPr>
               <a:t>EDITABLE DELIVERABLES</a:t>
             </a:r>
-            <a:endParaRPr sz="1200" b="0" i="0">
-              <a:solidFill>
-                <a:srgbClr val="177CB0"/>
-              </a:solidFill>
-              <a:latin typeface="微软雅黑" panose="020B0503020204020204" charset="-122"/>
-              <a:ea typeface="微软雅黑" panose="020B0503020204020204" charset="-122"/>
-            </a:endParaRPr>
           </a:p>
         </p:txBody>
       </p:sp>
@@ -11335,18 +10706,11 @@
                 <a:solidFill>
                   <a:srgbClr val="50616D"/>
                 </a:solidFill>
-                <a:latin typeface="微软雅黑" panose="020B0503020204020204" charset="-122"/>
-                <a:ea typeface="微软雅黑" panose="020B0503020204020204" charset="-122"/>
+                <a:latin typeface="微软雅黑"/>
+                <a:ea typeface="微软雅黑"/>
               </a:rPr>
               <a:t>要求技能产出可编辑格式，方便你二次核实与微调。科研场景尤其推荐 SVG 与 LaTeX→PDF。</a:t>
             </a:r>
-            <a:endParaRPr sz="1350" b="0" i="0">
-              <a:solidFill>
-                <a:srgbClr val="50616D"/>
-              </a:solidFill>
-              <a:latin typeface="微软雅黑" panose="020B0503020204020204" charset="-122"/>
-              <a:ea typeface="微软雅黑" panose="020B0503020204020204" charset="-122"/>
-            </a:endParaRPr>
           </a:p>
         </p:txBody>
       </p:sp>
@@ -11478,18 +10842,11 @@
                 <a:solidFill>
                   <a:srgbClr val="FFFFFF"/>
                 </a:solidFill>
-                <a:latin typeface="宋体" panose="02010600030101010101" pitchFamily="2" charset="-122"/>
-                <a:ea typeface="宋体" panose="02010600030101010101" pitchFamily="2" charset="-122"/>
+                <a:latin typeface="宋体"/>
+                <a:ea typeface="宋体"/>
               </a:rPr>
               <a:t>SVG</a:t>
             </a:r>
-            <a:endParaRPr sz="2600" b="1" i="0">
-              <a:solidFill>
-                <a:srgbClr val="FFFFFF"/>
-              </a:solidFill>
-              <a:latin typeface="宋体" panose="02010600030101010101" pitchFamily="2" charset="-122"/>
-              <a:ea typeface="宋体" panose="02010600030101010101" pitchFamily="2" charset="-122"/>
-            </a:endParaRPr>
           </a:p>
         </p:txBody>
       </p:sp>
@@ -11531,18 +10888,11 @@
                 <a:solidFill>
                   <a:srgbClr val="50616D"/>
                 </a:solidFill>
-                <a:latin typeface="微软雅黑" panose="020B0503020204020204" charset="-122"/>
-                <a:ea typeface="微软雅黑" panose="020B0503020204020204" charset="-122"/>
+                <a:latin typeface="微软雅黑"/>
+                <a:ea typeface="微软雅黑"/>
               </a:rPr>
               <a:t>矢量图、流程图、科研配图，可无损缩放与逐元素编辑</a:t>
             </a:r>
-            <a:endParaRPr sz="1250" b="0" i="0">
-              <a:solidFill>
-                <a:srgbClr val="50616D"/>
-              </a:solidFill>
-              <a:latin typeface="微软雅黑" panose="020B0503020204020204" charset="-122"/>
-              <a:ea typeface="微软雅黑" panose="020B0503020204020204" charset="-122"/>
-            </a:endParaRPr>
           </a:p>
         </p:txBody>
       </p:sp>
@@ -11674,18 +11024,11 @@
                 <a:solidFill>
                   <a:srgbClr val="FFFFFF"/>
                 </a:solidFill>
-                <a:latin typeface="宋体" panose="02010600030101010101" pitchFamily="2" charset="-122"/>
-                <a:ea typeface="宋体" panose="02010600030101010101" pitchFamily="2" charset="-122"/>
+                <a:latin typeface="宋体"/>
+                <a:ea typeface="宋体"/>
               </a:rPr>
               <a:t>PPT</a:t>
             </a:r>
-            <a:endParaRPr sz="2600" b="1" i="0">
-              <a:solidFill>
-                <a:srgbClr val="FFFFFF"/>
-              </a:solidFill>
-              <a:latin typeface="宋体" panose="02010600030101010101" pitchFamily="2" charset="-122"/>
-              <a:ea typeface="宋体" panose="02010600030101010101" pitchFamily="2" charset="-122"/>
-            </a:endParaRPr>
           </a:p>
         </p:txBody>
       </p:sp>
@@ -11727,18 +11070,11 @@
                 <a:solidFill>
                   <a:srgbClr val="50616D"/>
                 </a:solidFill>
-                <a:latin typeface="微软雅黑" panose="020B0503020204020204" charset="-122"/>
-                <a:ea typeface="微软雅黑" panose="020B0503020204020204" charset="-122"/>
+                <a:latin typeface="微软雅黑"/>
+                <a:ea typeface="微软雅黑"/>
               </a:rPr>
               <a:t>汇报、答辩、模板，形状与文字均可在 PowerPoint 内改</a:t>
             </a:r>
-            <a:endParaRPr sz="1250" b="0" i="0">
-              <a:solidFill>
-                <a:srgbClr val="50616D"/>
-              </a:solidFill>
-              <a:latin typeface="微软雅黑" panose="020B0503020204020204" charset="-122"/>
-              <a:ea typeface="微软雅黑" panose="020B0503020204020204" charset="-122"/>
-            </a:endParaRPr>
           </a:p>
         </p:txBody>
       </p:sp>
@@ -11870,18 +11206,11 @@
                 <a:solidFill>
                   <a:srgbClr val="FFFFFF"/>
                 </a:solidFill>
-                <a:latin typeface="宋体" panose="02010600030101010101" pitchFamily="2" charset="-122"/>
-                <a:ea typeface="宋体" panose="02010600030101010101" pitchFamily="2" charset="-122"/>
+                <a:latin typeface="宋体"/>
+                <a:ea typeface="宋体"/>
               </a:rPr>
               <a:t>PDF</a:t>
             </a:r>
-            <a:endParaRPr sz="2600" b="1" i="0">
-              <a:solidFill>
-                <a:srgbClr val="FFFFFF"/>
-              </a:solidFill>
-              <a:latin typeface="宋体" panose="02010600030101010101" pitchFamily="2" charset="-122"/>
-              <a:ea typeface="宋体" panose="02010600030101010101" pitchFamily="2" charset="-122"/>
-            </a:endParaRPr>
           </a:p>
         </p:txBody>
       </p:sp>
@@ -11923,18 +11252,11 @@
                 <a:solidFill>
                   <a:srgbClr val="50616D"/>
                 </a:solidFill>
-                <a:latin typeface="微软雅黑" panose="020B0503020204020204" charset="-122"/>
-                <a:ea typeface="微软雅黑" panose="020B0503020204020204" charset="-122"/>
+                <a:latin typeface="微软雅黑"/>
+                <a:ea typeface="微软雅黑"/>
               </a:rPr>
               <a:t>LaTeX 生成的论文级排版，公式与版式稳定</a:t>
             </a:r>
-            <a:endParaRPr sz="1250" b="0" i="0">
-              <a:solidFill>
-                <a:srgbClr val="50616D"/>
-              </a:solidFill>
-              <a:latin typeface="微软雅黑" panose="020B0503020204020204" charset="-122"/>
-              <a:ea typeface="微软雅黑" panose="020B0503020204020204" charset="-122"/>
-            </a:endParaRPr>
           </a:p>
         </p:txBody>
       </p:sp>
@@ -12064,8 +11386,8 @@
                 <a:solidFill>
                   <a:srgbClr val="161823"/>
                 </a:solidFill>
-                <a:latin typeface="微软雅黑" panose="020B0503020204020204" charset="-122"/>
-                <a:ea typeface="微软雅黑" panose="020B0503020204020204" charset="-122"/>
+                <a:latin typeface="微软雅黑"/>
+                <a:ea typeface="微软雅黑"/>
               </a:rPr>
               <a:t>成稿常有细微偏移或重叠，需要你自行核实修改。下一页说明：</a:t>
             </a:r>
@@ -12074,18 +11396,11 @@
                 <a:solidFill>
                   <a:srgbClr val="065279"/>
                 </a:solidFill>
-                <a:latin typeface="微软雅黑" panose="020B0503020204020204" charset="-122"/>
-                <a:ea typeface="微软雅黑" panose="020B0503020204020204" charset="-122"/>
+                <a:latin typeface="微软雅黑"/>
+                <a:ea typeface="微软雅黑"/>
               </a:rPr>
               <a:t>哪些该自己动手。</a:t>
             </a:r>
-            <a:endParaRPr sz="1300" b="1" i="0">
-              <a:solidFill>
-                <a:srgbClr val="065279"/>
-              </a:solidFill>
-              <a:latin typeface="微软雅黑" panose="020B0503020204020204" charset="-122"/>
-              <a:ea typeface="微软雅黑" panose="020B0503020204020204" charset="-122"/>
-            </a:endParaRPr>
           </a:p>
         </p:txBody>
       </p:sp>
@@ -12098,7 +11413,7 @@
 </file>
 
 <file path=ppt/slides/slide8.xml><?xml version="1.0" encoding="utf-8"?>
-<p:sld xmlns:a="http://schemas.openxmlformats.org/drawingml/2006/main" xmlns:r="http://schemas.openxmlformats.org/officeDocument/2006/relationships" xmlns:p="http://schemas.openxmlformats.org/presentationml/2006/main">
+<p:sld xmlns:a="http://schemas.openxmlformats.org/drawingml/2006/main" xmlns:p="http://schemas.openxmlformats.org/presentationml/2006/main" xmlns:r="http://schemas.openxmlformats.org/officeDocument/2006/relationships">
   <p:cSld>
     <p:bg>
       <p:bgPr>
@@ -12117,14 +11432,14 @@
       <p:grpSpPr/>
       <p:pic>
         <p:nvPicPr>
-          <p:cNvPr id="2" name="Picture 1" descr="paper_texture.png"/>
+          <p:cNvPr id="2" name="Picture 1" descr="rice_paper_bg.png"/>
           <p:cNvPicPr>
             <a:picLocks noChangeAspect="1"/>
           </p:cNvPicPr>
           <p:nvPr/>
         </p:nvPicPr>
         <p:blipFill>
-          <a:blip r:embed="rId1"/>
+          <a:blip r:embed="rId2"/>
           <a:stretch>
             <a:fillRect/>
           </a:stretch>
@@ -12235,7 +11550,7 @@
         </p:nvSpPr>
         <p:spPr>
           <a:xfrm>
-            <a:off x="475615" y="603504"/>
+            <a:off x="640080" y="603504"/>
             <a:ext cx="548640" cy="457200"/>
           </a:xfrm>
           <a:prstGeom prst="rect">
@@ -12265,18 +11580,11 @@
                 <a:solidFill>
                   <a:srgbClr val="FFFBF0"/>
                 </a:solidFill>
-                <a:latin typeface="宋体" panose="02010600030101010101" pitchFamily="2" charset="-122"/>
-                <a:ea typeface="宋体" panose="02010600030101010101" pitchFamily="2" charset="-122"/>
+                <a:latin typeface="宋体"/>
+                <a:ea typeface="宋体"/>
               </a:rPr>
               <a:t>界</a:t>
             </a:r>
-            <a:endParaRPr sz="1500" b="1" i="0">
-              <a:solidFill>
-                <a:srgbClr val="FFFBF0"/>
-              </a:solidFill>
-              <a:latin typeface="宋体" panose="02010600030101010101" pitchFamily="2" charset="-122"/>
-              <a:ea typeface="宋体" panose="02010600030101010101" pitchFamily="2" charset="-122"/>
-            </a:endParaRPr>
           </a:p>
         </p:txBody>
       </p:sp>
@@ -12318,18 +11626,11 @@
                 <a:solidFill>
                   <a:srgbClr val="161823"/>
                 </a:solidFill>
-                <a:latin typeface="宋体" panose="02010600030101010101" pitchFamily="2" charset="-122"/>
-                <a:ea typeface="宋体" panose="02010600030101010101" pitchFamily="2" charset="-122"/>
+                <a:latin typeface="宋体"/>
+                <a:ea typeface="宋体"/>
               </a:rPr>
               <a:t>微调的边界 · 各司其职</a:t>
             </a:r>
-            <a:endParaRPr sz="2700" b="1" i="0">
-              <a:solidFill>
-                <a:srgbClr val="161823"/>
-              </a:solidFill>
-              <a:latin typeface="宋体" panose="02010600030101010101" pitchFamily="2" charset="-122"/>
-              <a:ea typeface="宋体" panose="02010600030101010101" pitchFamily="2" charset="-122"/>
-            </a:endParaRPr>
           </a:p>
         </p:txBody>
       </p:sp>
@@ -12371,18 +11672,11 @@
                 <a:solidFill>
                   <a:srgbClr val="177CB0"/>
                 </a:solidFill>
-                <a:latin typeface="微软雅黑" panose="020B0503020204020204" charset="-122"/>
-                <a:ea typeface="微软雅黑" panose="020B0503020204020204" charset="-122"/>
+                <a:latin typeface="微软雅黑"/>
+                <a:ea typeface="微软雅黑"/>
               </a:rPr>
               <a:t>WHERE AI HELPS, WHERE YOU DO</a:t>
             </a:r>
-            <a:endParaRPr sz="1200" b="0" i="0">
-              <a:solidFill>
-                <a:srgbClr val="177CB0"/>
-              </a:solidFill>
-              <a:latin typeface="微软雅黑" panose="020B0503020204020204" charset="-122"/>
-              <a:ea typeface="微软雅黑" panose="020B0503020204020204" charset="-122"/>
-            </a:endParaRPr>
           </a:p>
         </p:txBody>
       </p:sp>
@@ -12550,18 +11844,11 @@
                 <a:solidFill>
                   <a:srgbClr val="FFFFFF"/>
                 </a:solidFill>
-                <a:latin typeface="微软雅黑" panose="020B0503020204020204" charset="-122"/>
-                <a:ea typeface="微软雅黑" panose="020B0503020204020204" charset="-122"/>
+                <a:latin typeface="微软雅黑"/>
+                <a:ea typeface="微软雅黑"/>
               </a:rPr>
               <a:t>交给 AI</a:t>
             </a:r>
-            <a:endParaRPr sz="1700" b="1" i="0">
-              <a:solidFill>
-                <a:srgbClr val="FFFFFF"/>
-              </a:solidFill>
-              <a:latin typeface="微软雅黑" panose="020B0503020204020204" charset="-122"/>
-              <a:ea typeface="微软雅黑" panose="020B0503020204020204" charset="-122"/>
-            </a:endParaRPr>
           </a:p>
         </p:txBody>
       </p:sp>
@@ -12647,18 +11934,11 @@
                 <a:solidFill>
                   <a:srgbClr val="161823"/>
                 </a:solidFill>
-                <a:latin typeface="微软雅黑" panose="020B0503020204020204" charset="-122"/>
-                <a:ea typeface="微软雅黑" panose="020B0503020204020204" charset="-122"/>
+                <a:latin typeface="微软雅黑"/>
+                <a:ea typeface="微软雅黑"/>
               </a:rPr>
               <a:t>结构、配色、版式与内容草稿</a:t>
             </a:r>
-            <a:endParaRPr sz="1300" b="0" i="0">
-              <a:solidFill>
-                <a:srgbClr val="161823"/>
-              </a:solidFill>
-              <a:latin typeface="微软雅黑" panose="020B0503020204020204" charset="-122"/>
-              <a:ea typeface="微软雅黑" panose="020B0503020204020204" charset="-122"/>
-            </a:endParaRPr>
           </a:p>
         </p:txBody>
       </p:sp>
@@ -12744,18 +12024,11 @@
                 <a:solidFill>
                   <a:srgbClr val="161823"/>
                 </a:solidFill>
-                <a:latin typeface="微软雅黑" panose="020B0503020204020204" charset="-122"/>
-                <a:ea typeface="微软雅黑" panose="020B0503020204020204" charset="-122"/>
+                <a:latin typeface="微软雅黑"/>
+                <a:ea typeface="微软雅黑"/>
               </a:rPr>
               <a:t>生成可编辑的 SVG / PPT / PDF</a:t>
             </a:r>
-            <a:endParaRPr sz="1300" b="0" i="0">
-              <a:solidFill>
-                <a:srgbClr val="161823"/>
-              </a:solidFill>
-              <a:latin typeface="微软雅黑" panose="020B0503020204020204" charset="-122"/>
-              <a:ea typeface="微软雅黑" panose="020B0503020204020204" charset="-122"/>
-            </a:endParaRPr>
           </a:p>
         </p:txBody>
       </p:sp>
@@ -12841,18 +12114,11 @@
                 <a:solidFill>
                   <a:srgbClr val="161823"/>
                 </a:solidFill>
-                <a:latin typeface="微软雅黑" panose="020B0503020204020204" charset="-122"/>
-                <a:ea typeface="微软雅黑" panose="020B0503020204020204" charset="-122"/>
+                <a:latin typeface="微软雅黑"/>
+                <a:ea typeface="微软雅黑"/>
               </a:rPr>
               <a:t>套用风格契约与色卡规范</a:t>
             </a:r>
-            <a:endParaRPr sz="1300" b="0" i="0">
-              <a:solidFill>
-                <a:srgbClr val="161823"/>
-              </a:solidFill>
-              <a:latin typeface="微软雅黑" panose="020B0503020204020204" charset="-122"/>
-              <a:ea typeface="微软雅黑" panose="020B0503020204020204" charset="-122"/>
-            </a:endParaRPr>
           </a:p>
         </p:txBody>
       </p:sp>
@@ -12938,18 +12204,11 @@
                 <a:solidFill>
                   <a:srgbClr val="161823"/>
                 </a:solidFill>
-                <a:latin typeface="微软雅黑" panose="020B0503020204020204" charset="-122"/>
-                <a:ea typeface="微软雅黑" panose="020B0503020204020204" charset="-122"/>
+                <a:latin typeface="微软雅黑"/>
+                <a:ea typeface="微软雅黑"/>
               </a:rPr>
               <a:t>批量铺排页面节奏与图表</a:t>
             </a:r>
-            <a:endParaRPr sz="1300" b="0" i="0">
-              <a:solidFill>
-                <a:srgbClr val="161823"/>
-              </a:solidFill>
-              <a:latin typeface="微软雅黑" panose="020B0503020204020204" charset="-122"/>
-              <a:ea typeface="微软雅黑" panose="020B0503020204020204" charset="-122"/>
-            </a:endParaRPr>
           </a:p>
         </p:txBody>
       </p:sp>
@@ -13081,18 +12340,11 @@
                 <a:solidFill>
                   <a:srgbClr val="FFFFFF"/>
                 </a:solidFill>
-                <a:latin typeface="微软雅黑" panose="020B0503020204020204" charset="-122"/>
-                <a:ea typeface="微软雅黑" panose="020B0503020204020204" charset="-122"/>
+                <a:latin typeface="微软雅黑"/>
+                <a:ea typeface="微软雅黑"/>
               </a:rPr>
               <a:t>自己动手</a:t>
             </a:r>
-            <a:endParaRPr sz="1700" b="1" i="0">
-              <a:solidFill>
-                <a:srgbClr val="FFFFFF"/>
-              </a:solidFill>
-              <a:latin typeface="微软雅黑" panose="020B0503020204020204" charset="-122"/>
-              <a:ea typeface="微软雅黑" panose="020B0503020204020204" charset="-122"/>
-            </a:endParaRPr>
           </a:p>
         </p:txBody>
       </p:sp>
@@ -13178,18 +12430,11 @@
                 <a:solidFill>
                   <a:srgbClr val="161823"/>
                 </a:solidFill>
-                <a:latin typeface="微软雅黑" panose="020B0503020204020204" charset="-122"/>
-                <a:ea typeface="微软雅黑" panose="020B0503020204020204" charset="-122"/>
+                <a:latin typeface="微软雅黑"/>
+                <a:ea typeface="微软雅黑"/>
               </a:rPr>
               <a:t>像素级的位置与重叠微调</a:t>
             </a:r>
-            <a:endParaRPr sz="1300" b="0" i="0">
-              <a:solidFill>
-                <a:srgbClr val="161823"/>
-              </a:solidFill>
-              <a:latin typeface="微软雅黑" panose="020B0503020204020204" charset="-122"/>
-              <a:ea typeface="微软雅黑" panose="020B0503020204020204" charset="-122"/>
-            </a:endParaRPr>
           </a:p>
         </p:txBody>
       </p:sp>
@@ -13275,18 +12520,11 @@
                 <a:solidFill>
                   <a:srgbClr val="161823"/>
                 </a:solidFill>
-                <a:latin typeface="微软雅黑" panose="020B0503020204020204" charset="-122"/>
-                <a:ea typeface="微软雅黑" panose="020B0503020204020204" charset="-122"/>
+                <a:latin typeface="微软雅黑"/>
+                <a:ea typeface="微软雅黑"/>
               </a:rPr>
               <a:t>字距、行高的最后一两步对齐</a:t>
             </a:r>
-            <a:endParaRPr sz="1300" b="0" i="0">
-              <a:solidFill>
-                <a:srgbClr val="161823"/>
-              </a:solidFill>
-              <a:latin typeface="微软雅黑" panose="020B0503020204020204" charset="-122"/>
-              <a:ea typeface="微软雅黑" panose="020B0503020204020204" charset="-122"/>
-            </a:endParaRPr>
           </a:p>
         </p:txBody>
       </p:sp>
@@ -13372,18 +12610,11 @@
                 <a:solidFill>
                   <a:srgbClr val="161823"/>
                 </a:solidFill>
-                <a:latin typeface="微软雅黑" panose="020B0503020204020204" charset="-122"/>
-                <a:ea typeface="微软雅黑" panose="020B0503020204020204" charset="-122"/>
+                <a:latin typeface="微软雅黑"/>
+                <a:ea typeface="微软雅黑"/>
               </a:rPr>
               <a:t>事实、数据与措辞的终审</a:t>
             </a:r>
-            <a:endParaRPr sz="1300" b="0" i="0">
-              <a:solidFill>
-                <a:srgbClr val="161823"/>
-              </a:solidFill>
-              <a:latin typeface="微软雅黑" panose="020B0503020204020204" charset="-122"/>
-              <a:ea typeface="微软雅黑" panose="020B0503020204020204" charset="-122"/>
-            </a:endParaRPr>
           </a:p>
         </p:txBody>
       </p:sp>
@@ -13469,18 +12700,11 @@
                 <a:solidFill>
                   <a:srgbClr val="161823"/>
                 </a:solidFill>
-                <a:latin typeface="微软雅黑" panose="020B0503020204020204" charset="-122"/>
-                <a:ea typeface="微软雅黑" panose="020B0503020204020204" charset="-122"/>
+                <a:latin typeface="微软雅黑"/>
+                <a:ea typeface="微软雅黑"/>
               </a:rPr>
               <a:t>导出后在原生软件里的精修</a:t>
             </a:r>
-            <a:endParaRPr sz="1300" b="0" i="0">
-              <a:solidFill>
-                <a:srgbClr val="161823"/>
-              </a:solidFill>
-              <a:latin typeface="微软雅黑" panose="020B0503020204020204" charset="-122"/>
-              <a:ea typeface="微软雅黑" panose="020B0503020204020204" charset="-122"/>
-            </a:endParaRPr>
           </a:p>
         </p:txBody>
       </p:sp>
@@ -13566,18 +12790,11 @@
                 <a:solidFill>
                   <a:srgbClr val="D6ECF0"/>
                 </a:solidFill>
-                <a:latin typeface="楷体" panose="02010609060101010101" charset="-122"/>
-                <a:ea typeface="楷体" panose="02010609060101010101" charset="-122"/>
+                <a:latin typeface="楷体"/>
+                <a:ea typeface="楷体"/>
               </a:rPr>
               <a:t>微调不要依赖 AI——目前它不擅长，反而拖慢效率。把精修留给自己，把铺量交给智能体。</a:t>
             </a:r>
-            <a:endParaRPr sz="1250" b="0" i="0">
-              <a:solidFill>
-                <a:srgbClr val="D6ECF0"/>
-              </a:solidFill>
-              <a:latin typeface="楷体" panose="02010609060101010101" charset="-122"/>
-              <a:ea typeface="楷体" panose="02010609060101010101" charset="-122"/>
-            </a:endParaRPr>
           </a:p>
         </p:txBody>
       </p:sp>
@@ -13590,7 +12807,7 @@
 </file>
 
 <file path=ppt/slides/slide9.xml><?xml version="1.0" encoding="utf-8"?>
-<p:sld xmlns:a="http://schemas.openxmlformats.org/drawingml/2006/main" xmlns:r="http://schemas.openxmlformats.org/officeDocument/2006/relationships" xmlns:p="http://schemas.openxmlformats.org/presentationml/2006/main">
+<p:sld xmlns:a="http://schemas.openxmlformats.org/drawingml/2006/main" xmlns:p="http://schemas.openxmlformats.org/presentationml/2006/main" xmlns:r="http://schemas.openxmlformats.org/officeDocument/2006/relationships">
   <p:cSld>
     <p:bg>
       <p:bgPr>
@@ -13607,9 +12824,33 @@
         <p:nvPr/>
       </p:nvGrpSpPr>
       <p:grpSpPr/>
+      <p:pic>
+        <p:nvPicPr>
+          <p:cNvPr id="2" name="Picture 1" descr="border_gold.png"/>
+          <p:cNvPicPr>
+            <a:picLocks noChangeAspect="1"/>
+          </p:cNvPicPr>
+          <p:nvPr/>
+        </p:nvPicPr>
+        <p:blipFill>
+          <a:blip r:embed="rId2"/>
+          <a:stretch>
+            <a:fillRect/>
+          </a:stretch>
+        </p:blipFill>
+        <p:spPr>
+          <a:xfrm>
+            <a:off x="3950208" y="457200"/>
+            <a:ext cx="4297680" cy="1688675"/>
+          </a:xfrm>
+          <a:prstGeom prst="rect">
+            <a:avLst/>
+          </a:prstGeom>
+        </p:spPr>
+      </p:pic>
       <p:cxnSp>
         <p:nvCxnSpPr>
-          <p:cNvPr id="2" name="Connector 1"/>
+          <p:cNvPr id="3" name="Connector 2"/>
           <p:cNvCxnSpPr/>
           <p:nvPr/>
         </p:nvCxnSpPr>
@@ -13645,14 +12886,14 @@
       </p:cxnSp>
       <p:sp>
         <p:nvSpPr>
-          <p:cNvPr id="3" name="TextBox 2"/>
+          <p:cNvPr id="4" name="TextBox 3"/>
           <p:cNvSpPr txBox="1"/>
           <p:nvPr/>
         </p:nvSpPr>
         <p:spPr>
           <a:xfrm>
             <a:off x="1188720" y="2468880"/>
-            <a:ext cx="10058400" cy="1906905"/>
+            <a:ext cx="10058400" cy="2011680"/>
           </a:xfrm>
           <a:prstGeom prst="rect">
             <a:avLst/>
@@ -13681,18 +12922,11 @@
                 <a:solidFill>
                   <a:srgbClr val="FFFBF0"/>
                 </a:solidFill>
-                <a:latin typeface="宋体" panose="02010600030101010101" pitchFamily="2" charset="-122"/>
-                <a:ea typeface="宋体" panose="02010600030101010101" pitchFamily="2" charset="-122"/>
+                <a:latin typeface="宋体"/>
+                <a:ea typeface="宋体"/>
               </a:rPr>
               <a:t>装上技能，描述意图，</a:t>
             </a:r>
-            <a:endParaRPr sz="3000" b="1" i="0">
-              <a:solidFill>
-                <a:srgbClr val="FFFBF0"/>
-              </a:solidFill>
-              <a:latin typeface="宋体" panose="02010600030101010101" pitchFamily="2" charset="-122"/>
-              <a:ea typeface="宋体" panose="02010600030101010101" pitchFamily="2" charset="-122"/>
-            </a:endParaRPr>
           </a:p>
           <a:p>
             <a:pPr algn="l">
@@ -13711,44 +12945,17 @@
                 <a:solidFill>
                   <a:srgbClr val="FFFBF0"/>
                 </a:solidFill>
-                <a:latin typeface="宋体" panose="02010600030101010101" pitchFamily="2" charset="-122"/>
-                <a:ea typeface="宋体" panose="02010600030101010101" pitchFamily="2" charset="-122"/>
+                <a:latin typeface="宋体"/>
+                <a:ea typeface="宋体"/>
               </a:rPr>
               <a:t>把初稿交给智能体，把精修留给自己。</a:t>
             </a:r>
-            <a:endParaRPr sz="3000" b="1" i="0">
-              <a:solidFill>
-                <a:srgbClr val="FFFBF0"/>
-              </a:solidFill>
-              <a:latin typeface="宋体" panose="02010600030101010101" pitchFamily="2" charset="-122"/>
-              <a:ea typeface="宋体" panose="02010600030101010101" pitchFamily="2" charset="-122"/>
-            </a:endParaRPr>
-          </a:p>
-          <a:p>
-            <a:pPr algn="l">
-              <a:lnSpc>
-                <a:spcPct val="120000"/>
-              </a:lnSpc>
-              <a:spcBef>
-                <a:spcPts val="0"/>
-              </a:spcBef>
-              <a:spcAft>
-                <a:spcPts val="600"/>
-              </a:spcAft>
-            </a:pPr>
-            <a:endParaRPr lang="en-US" sz="3000" b="1" i="0">
-              <a:solidFill>
-                <a:srgbClr val="FFFBF0"/>
-              </a:solidFill>
-              <a:latin typeface="宋体" panose="02010600030101010101" pitchFamily="2" charset="-122"/>
-              <a:ea typeface="宋体" panose="02010600030101010101" pitchFamily="2" charset="-122"/>
-            </a:endParaRPr>
-          </a:p>
-        </p:txBody>
-      </p:sp>
-      <p:sp>
-        <p:nvSpPr>
-          <p:cNvPr id="4" name="TextBox 3"/>
+          </a:p>
+        </p:txBody>
+      </p:sp>
+      <p:sp>
+        <p:nvSpPr>
+          <p:cNvPr id="5" name="TextBox 4"/>
           <p:cNvSpPr txBox="1"/>
           <p:nvPr/>
         </p:nvSpPr>
@@ -13784,24 +12991,17 @@
                 <a:solidFill>
                   <a:srgbClr val="A1AFC9"/>
                 </a:solidFill>
-                <a:latin typeface="微软雅黑" panose="020B0503020204020204" charset="-122"/>
-                <a:ea typeface="微软雅黑" panose="020B0503020204020204" charset="-122"/>
+                <a:latin typeface="微软雅黑"/>
+                <a:ea typeface="微软雅黑"/>
               </a:rPr>
               <a:t>Install the skill · describe the intent · let the agent draft, you refine.</a:t>
             </a:r>
-            <a:endParaRPr sz="1300" b="0" i="0">
-              <a:solidFill>
-                <a:srgbClr val="A1AFC9"/>
-              </a:solidFill>
-              <a:latin typeface="微软雅黑" panose="020B0503020204020204" charset="-122"/>
-              <a:ea typeface="微软雅黑" panose="020B0503020204020204" charset="-122"/>
-            </a:endParaRPr>
-          </a:p>
-        </p:txBody>
-      </p:sp>
-      <p:sp>
-        <p:nvSpPr>
-          <p:cNvPr id="5" name="Oval 4"/>
+          </a:p>
+        </p:txBody>
+      </p:sp>
+      <p:sp>
+        <p:nvSpPr>
+          <p:cNvPr id="6" name="Oval 5"/>
           <p:cNvSpPr/>
           <p:nvPr/>
         </p:nvSpPr>
@@ -13845,13 +13045,13 @@
       </p:sp>
       <p:sp>
         <p:nvSpPr>
-          <p:cNvPr id="6" name="TextBox 5"/>
+          <p:cNvPr id="7" name="TextBox 6"/>
           <p:cNvSpPr txBox="1"/>
           <p:nvPr/>
         </p:nvSpPr>
         <p:spPr>
           <a:xfrm>
-            <a:off x="978408" y="5276088"/>
+            <a:off x="1298448" y="5276088"/>
             <a:ext cx="914400" cy="457200"/>
           </a:xfrm>
           <a:prstGeom prst="rect">
@@ -13881,31 +13081,24 @@
                 <a:solidFill>
                   <a:srgbClr val="FFFBF0"/>
                 </a:solidFill>
-                <a:latin typeface="楷体" panose="02010609060101010101" charset="-122"/>
-                <a:ea typeface="楷体" panose="02010609060101010101" charset="-122"/>
+                <a:latin typeface="楷体"/>
+                <a:ea typeface="楷体"/>
               </a:rPr>
               <a:t>匠</a:t>
             </a:r>
-            <a:endParaRPr sz="1700" b="1" i="0">
-              <a:solidFill>
-                <a:srgbClr val="FFFBF0"/>
-              </a:solidFill>
-              <a:latin typeface="楷体" panose="02010609060101010101" charset="-122"/>
-              <a:ea typeface="楷体" panose="02010609060101010101" charset="-122"/>
-            </a:endParaRPr>
-          </a:p>
-        </p:txBody>
-      </p:sp>
-      <p:sp>
-        <p:nvSpPr>
-          <p:cNvPr id="7" name="TextBox 6"/>
+          </a:p>
+        </p:txBody>
+      </p:sp>
+      <p:sp>
+        <p:nvSpPr>
+          <p:cNvPr id="8" name="TextBox 7"/>
           <p:cNvSpPr txBox="1"/>
           <p:nvPr/>
         </p:nvSpPr>
         <p:spPr>
           <a:xfrm>
-            <a:off x="1828800" y="5321173"/>
-            <a:ext cx="9144000" cy="275590"/>
+            <a:off x="1828800" y="5230368"/>
+            <a:ext cx="9144000" cy="457200"/>
           </a:xfrm>
           <a:prstGeom prst="rect">
             <a:avLst/>
@@ -13930,33 +13123,15 @@
               </a:spcAft>
             </a:pPr>
             <a:r>
-              <a:rPr lang="en-US" sz="1200" b="1">
-                <a:solidFill>
-                  <a:srgbClr val="FFFBF0"/>
-                </a:solidFill>
-                <a:latin typeface="宋体" panose="02010600030101010101" pitchFamily="2" charset="-122"/>
-                <a:ea typeface="宋体" panose="02010600030101010101" pitchFamily="2" charset="-122"/>
-                <a:sym typeface="+mn-ea"/>
-              </a:rPr>
-              <a:t>Created by Claude opus 4.8, </a:t>
-            </a:r>
-            <a:r>
               <a:rPr sz="1200" b="0" i="0">
                 <a:solidFill>
                   <a:srgbClr val="D6ECF0"/>
                 </a:solidFill>
-                <a:latin typeface="微软雅黑" panose="020B0503020204020204" charset="-122"/>
-                <a:ea typeface="微软雅黑" panose="020B0503020204020204" charset="-122"/>
+                <a:latin typeface="微软雅黑"/>
+                <a:ea typeface="微软雅黑"/>
               </a:rPr>
               <a:t>my-design-style · chinese_traditional_color_style · 靛青学者 × 墨纸</a:t>
             </a:r>
-            <a:endParaRPr sz="1200" b="0" i="0">
-              <a:solidFill>
-                <a:srgbClr val="D6ECF0"/>
-              </a:solidFill>
-              <a:latin typeface="微软雅黑" panose="020B0503020204020204" charset="-122"/>
-              <a:ea typeface="微软雅黑" panose="020B0503020204020204" charset="-122"/>
-            </a:endParaRPr>
           </a:p>
         </p:txBody>
       </p:sp>
@@ -14284,10 +13459,6 @@
       </a:style>
     </a:lnDef>
   </a:objectDefaults>
-  <a:extLst>
-    <a:ext uri="{05A4C25C-085E-4340-85A3-A5531E510DB2}">
-      <thm15:themeFamily xmlns:thm15="http://schemas.microsoft.com/office/thememl/2012/main" name="Office Theme" id="{62F939B6-93AF-4DB8-9C6B-D6C7DFDC589F}" vid="{4A3C46E8-61CC-4603-A589-7422A47A8E4A}"/>
-    </a:ext>
-  </a:extLst>
+  <a:extraClrSchemeLst/>
 </a:theme>
 </file>
</xml_diff>